<commit_message>
cambios en la ppt
</commit_message>
<xml_diff>
--- a/NEW-WORLD-TELECOM.pptx
+++ b/NEW-WORLD-TELECOM.pptx
@@ -1,9 +1,12 @@
 
 <file path=ppt/presentation.xml><?xml version="1.0" encoding="utf-8"?>
-<p:presentation xmlns:a="http://schemas.openxmlformats.org/drawingml/2006/main" xmlns:r="http://schemas.openxmlformats.org/officeDocument/2006/relationships" xmlns:p="http://schemas.openxmlformats.org/presentationml/2006/main" saveSubsetFonts="true" autoCompressPictures="0" embedTrueTypeFonts="true">
+<p:presentation xmlns:a="http://schemas.openxmlformats.org/drawingml/2006/main" xmlns:r="http://schemas.openxmlformats.org/officeDocument/2006/relationships" xmlns:p="http://schemas.openxmlformats.org/presentationml/2006/main" embedTrueTypeFonts="1" saveSubsetFonts="1" autoCompressPictures="0">
   <p:sldMasterIdLst>
     <p:sldMasterId id="2147483648" r:id="rId1"/>
   </p:sldMasterIdLst>
+  <p:notesMasterIdLst>
+    <p:notesMasterId r:id="rId13"/>
+  </p:notesMasterIdLst>
   <p:sldIdLst>
     <p:sldId id="256" r:id="rId2"/>
     <p:sldId id="257" r:id="rId3"/>
@@ -17,35 +20,20 @@
     <p:sldId id="265" r:id="rId11"/>
     <p:sldId id="266" r:id="rId12"/>
   </p:sldIdLst>
-  <p:notesMasterIdLst>
-    <p:notesMasterId r:id="rId13"/>
-  </p:notesMasterIdLst>
-  <p:sldSz cx="12191695" cy="6858000"/>
-  <p:notesSz cx="6858000" cy="12191695"/>
+  <p:sldSz cx="12192000" cy="6858000"/>
+  <p:notesSz cx="6858000" cy="12192000"/>
   <p:embeddedFontLst>
     <p:embeddedFont>
-      <p:font typeface="DM Sans"/>
-      <p:regular r:id="rId201314"/>
+      <p:font typeface="DM Sans Medium" pitchFamily="2" charset="0"/>
+      <p:regular r:id="rId14"/>
     </p:embeddedFont>
     <p:embeddedFont>
-      <p:font typeface="DM Sans Medium"/>
-      <p:regular r:id="rId201315"/>
+      <p:font typeface="Inter" panose="020B0604020202020204" charset="0"/>
+      <p:regular r:id="rId15"/>
     </p:embeddedFont>
     <p:embeddedFont>
-      <p:font typeface="DM Sans Bold"/>
-      <p:regular r:id="rId201316"/>
-    </p:embeddedFont>
-    <p:embeddedFont>
-      <p:font typeface="Inter Medium"/>
-      <p:regular r:id="rId201317"/>
-    </p:embeddedFont>
-    <p:embeddedFont>
-      <p:font typeface="Inter Bold"/>
-      <p:regular r:id="rId201318"/>
-    </p:embeddedFont>
-    <p:embeddedFont>
-      <p:font typeface="Inter"/>
-      <p:regular r:id="rId201319"/>
+      <p:font typeface="Inter Bold" panose="020B0604020202020204" charset="0"/>
+      <p:regular r:id="rId16"/>
     </p:embeddedFont>
   </p:embeddedFontLst>
   <p:defaultTextStyle>
@@ -140,6 +128,11 @@
       </a:defRPr>
     </a:lvl9pPr>
   </p:defaultTextStyle>
+  <p:extLst>
+    <p:ext uri="{EFAFB233-063F-42B5-8137-9DF3F51BA10A}">
+      <p15:sldGuideLst xmlns:p15="http://schemas.microsoft.com/office/powerpoint/2012/main"/>
+    </p:ext>
+  </p:extLst>
 </p:presentation>
 </file>
 
@@ -165,234 +158,10 @@
           <a:chExt cx="0" cy="0"/>
         </a:xfrm>
       </p:grpSpPr>
-      <p:sp>
-        <p:nvSpPr>
-          <p:cNvPr id="2" name="Header Placeholder 1"/>
-          <p:cNvSpPr>
-            <a:spLocks noGrp="1"/>
-          </p:cNvSpPr>
-          <p:nvPr>
-            <p:ph type="hdr" sz="quarter"/>
-          </p:nvPr>
-        </p:nvSpPr>
-        <p:spPr>
-          <a:xfrm>
-            <a:off x="0" y="0"/>
-            <a:ext cx="2971800" cy="458788"/>
-          </a:xfrm>
-          <a:prstGeom prst="rect">
-            <a:avLst/>
-          </a:prstGeom>
-        </p:spPr>
-        <p:txBody>
-          <a:bodyPr vert="horz" lIns="91440" tIns="45720" rIns="91440" bIns="45720" rtlCol="0"/>
-          <a:lstStyle>
-            <a:lvl1pPr algn="l">
-              <a:defRPr sz="1200"/>
-            </a:lvl1pPr>
-          </a:lstStyle>
-          <a:p>
-            <a:endParaRPr lang="en-US"/>
-          </a:p>
-        </p:txBody>
-      </p:sp>
-      <p:sp>
-        <p:nvSpPr>
-          <p:cNvPr id="3" name="Date Placeholder 2"/>
-          <p:cNvSpPr>
-            <a:spLocks noGrp="1"/>
-          </p:cNvSpPr>
-          <p:nvPr>
-            <p:ph type="dt" idx="1"/>
-          </p:nvPr>
-        </p:nvSpPr>
-        <p:spPr>
-          <a:xfrm>
-            <a:off x="3884613" y="0"/>
-            <a:ext cx="2971800" cy="458788"/>
-          </a:xfrm>
-          <a:prstGeom prst="rect">
-            <a:avLst/>
-          </a:prstGeom>
-        </p:spPr>
-        <p:txBody>
-          <a:bodyPr vert="horz" lIns="91440" tIns="45720" rIns="91440" bIns="45720" rtlCol="0"/>
-          <a:lstStyle>
-            <a:lvl1pPr algn="r">
-              <a:defRPr sz="1200"/>
-            </a:lvl1pPr>
-          </a:lstStyle>
-          <a:p>
-            <a:fld id="{5282F153-3F37-0F45-9E97-73ACFA13230C}" type="datetimeFigureOut">
-              <a:rPr lang="en-US"/>
-              <a:t>7/23/19</a:t>
-            </a:fld>
-            <a:endParaRPr lang="en-US"/>
-          </a:p>
-        </p:txBody>
-      </p:sp>
-      <p:sp>
-        <p:nvSpPr>
-          <p:cNvPr id="4" name="Slide Image Placeholder 3"/>
-          <p:cNvSpPr>
-            <a:spLocks noGrp="1" noRot="1" noChangeAspect="1"/>
-          </p:cNvSpPr>
-          <p:nvPr>
-            <p:ph type="sldImg" idx="2"/>
-          </p:nvPr>
-        </p:nvSpPr>
-        <p:spPr>
-          <a:xfrm>
-            <a:off x="685800" y="1143000"/>
-            <a:ext cx="5486400" cy="3086100"/>
-          </a:xfrm>
-          <a:prstGeom prst="rect">
-            <a:avLst/>
-          </a:prstGeom>
-          <a:noFill/>
-          <a:ln w="12700">
-            <a:solidFill>
-              <a:prstClr val="black"/>
-            </a:solidFill>
-          </a:ln>
-        </p:spPr>
-        <p:txBody>
-          <a:bodyPr vert="horz" lIns="91440" tIns="45720" rIns="91440" bIns="45720" rtlCol="0" anchor="ctr"/>
-          <a:lstStyle/>
-          <a:p>
-            <a:endParaRPr lang="en-US"/>
-          </a:p>
-        </p:txBody>
-      </p:sp>
-      <p:sp>
-        <p:nvSpPr>
-          <p:cNvPr id="5" name="Notes Placeholder 4"/>
-          <p:cNvSpPr>
-            <a:spLocks noGrp="1"/>
-          </p:cNvSpPr>
-          <p:nvPr>
-            <p:ph type="body" sz="quarter" idx="3"/>
-          </p:nvPr>
-        </p:nvSpPr>
-        <p:spPr>
-          <a:xfrm>
-            <a:off x="685800" y="4400550"/>
-            <a:ext cx="5486400" cy="3600450"/>
-          </a:xfrm>
-          <a:prstGeom prst="rect">
-            <a:avLst/>
-          </a:prstGeom>
-        </p:spPr>
-        <p:txBody>
-          <a:bodyPr vert="horz" lIns="91440" tIns="45720" rIns="91440" bIns="45720" rtlCol="0"/>
-          <a:lstStyle/>
-          <a:p>
-            <a:pPr lvl="0"/>
-            <a:r>
-              <a:rPr lang="en-US"/>
-              <a:t>Click to edit Master text styles</a:t>
-            </a:r>
-          </a:p>
-          <a:p>
-            <a:pPr lvl="1"/>
-            <a:r>
-              <a:rPr lang="en-US"/>
-              <a:t>Second level</a:t>
-            </a:r>
-          </a:p>
-          <a:p>
-            <a:pPr lvl="2"/>
-            <a:r>
-              <a:rPr lang="en-US"/>
-              <a:t>Third level</a:t>
-            </a:r>
-          </a:p>
-          <a:p>
-            <a:pPr lvl="3"/>
-            <a:r>
-              <a:rPr lang="en-US"/>
-              <a:t>Fourth level</a:t>
-            </a:r>
-          </a:p>
-          <a:p>
-            <a:pPr lvl="4"/>
-            <a:r>
-              <a:rPr lang="en-US"/>
-              <a:t>Fifth level</a:t>
-            </a:r>
-          </a:p>
-        </p:txBody>
-      </p:sp>
-      <p:sp>
-        <p:nvSpPr>
-          <p:cNvPr id="6" name="Footer Placeholder 5"/>
-          <p:cNvSpPr>
-            <a:spLocks noGrp="1"/>
-          </p:cNvSpPr>
-          <p:nvPr>
-            <p:ph type="ftr" sz="quarter" idx="4"/>
-          </p:nvPr>
-        </p:nvSpPr>
-        <p:spPr>
-          <a:xfrm>
-            <a:off x="0" y="8685213"/>
-            <a:ext cx="2971800" cy="458787"/>
-          </a:xfrm>
-          <a:prstGeom prst="rect">
-            <a:avLst/>
-          </a:prstGeom>
-        </p:spPr>
-        <p:txBody>
-          <a:bodyPr vert="horz" lIns="91440" tIns="45720" rIns="91440" bIns="45720" rtlCol="0" anchor="b"/>
-          <a:lstStyle>
-            <a:lvl1pPr algn="l">
-              <a:defRPr sz="1200"/>
-            </a:lvl1pPr>
-          </a:lstStyle>
-          <a:p>
-            <a:endParaRPr lang="en-US"/>
-          </a:p>
-        </p:txBody>
-      </p:sp>
-      <p:sp>
-        <p:nvSpPr>
-          <p:cNvPr id="7" name="Slide Number Placeholder 6"/>
-          <p:cNvSpPr>
-            <a:spLocks noGrp="1"/>
-          </p:cNvSpPr>
-          <p:nvPr>
-            <p:ph type="sldNum" sz="quarter" idx="5"/>
-          </p:nvPr>
-        </p:nvSpPr>
-        <p:spPr>
-          <a:xfrm>
-            <a:off x="3884613" y="8685213"/>
-            <a:ext cx="2971800" cy="458787"/>
-          </a:xfrm>
-          <a:prstGeom prst="rect">
-            <a:avLst/>
-          </a:prstGeom>
-        </p:spPr>
-        <p:txBody>
-          <a:bodyPr vert="horz" lIns="91440" tIns="45720" rIns="91440" bIns="45720" rtlCol="0" anchor="b"/>
-          <a:lstStyle>
-            <a:lvl1pPr algn="r">
-              <a:defRPr sz="1200"/>
-            </a:lvl1pPr>
-          </a:lstStyle>
-          <a:p>
-            <a:fld id="{CE5E9CC1-C706-0F49-92D6-E571CC5EEA8F}" type="slidenum">
-              <a:rPr lang="en-US"/>
-              <a:t>‹#›</a:t>
-            </a:fld>
-            <a:endParaRPr lang="en-US"/>
-          </a:p>
-        </p:txBody>
-      </p:sp>
     </p:spTree>
     <p:extLst>
       <p:ext uri="{BB962C8B-B14F-4D97-AF65-F5344CB8AC3E}">
-        <p14:creationId xmlns:p14="http://schemas.microsoft.com/office/powerpoint/2010/main" val="1024086991"/>
+        <p14:creationId xmlns:p14="http://schemas.microsoft.com/office/powerpoint/2010/main" val="3355469740"/>
       </p:ext>
     </p:extLst>
   </p:cSld>
@@ -536,10 +305,6 @@
           <a:bodyPr/>
           <a:lstStyle/>
           <a:p>
-            <a:r>
-              <a:rPr lang="en-US" dirty="0"/>
-              <a:t/>
-            </a:r>
             <a:endParaRPr lang="en-US" dirty="0"/>
           </a:p>
         </p:txBody>
@@ -624,10 +389,6 @@
           <a:bodyPr/>
           <a:lstStyle/>
           <a:p>
-            <a:r>
-              <a:rPr lang="en-US" dirty="0"/>
-              <a:t/>
-            </a:r>
             <a:endParaRPr lang="en-US" dirty="0"/>
           </a:p>
         </p:txBody>
@@ -712,10 +473,6 @@
           <a:bodyPr/>
           <a:lstStyle/>
           <a:p>
-            <a:r>
-              <a:rPr lang="en-US" dirty="0"/>
-              <a:t/>
-            </a:r>
             <a:endParaRPr lang="en-US" dirty="0"/>
           </a:p>
         </p:txBody>
@@ -800,10 +557,6 @@
           <a:bodyPr/>
           <a:lstStyle/>
           <a:p>
-            <a:r>
-              <a:rPr lang="en-US" dirty="0"/>
-              <a:t/>
-            </a:r>
             <a:endParaRPr lang="en-US" dirty="0"/>
           </a:p>
         </p:txBody>
@@ -888,10 +641,6 @@
           <a:bodyPr/>
           <a:lstStyle/>
           <a:p>
-            <a:r>
-              <a:rPr lang="en-US" dirty="0"/>
-              <a:t/>
-            </a:r>
             <a:endParaRPr lang="en-US" dirty="0"/>
           </a:p>
         </p:txBody>
@@ -976,10 +725,6 @@
           <a:bodyPr/>
           <a:lstStyle/>
           <a:p>
-            <a:r>
-              <a:rPr lang="en-US" dirty="0"/>
-              <a:t/>
-            </a:r>
             <a:endParaRPr lang="en-US" dirty="0"/>
           </a:p>
         </p:txBody>
@@ -1064,10 +809,6 @@
           <a:bodyPr/>
           <a:lstStyle/>
           <a:p>
-            <a:r>
-              <a:rPr lang="en-US" dirty="0"/>
-              <a:t/>
-            </a:r>
             <a:endParaRPr lang="en-US" dirty="0"/>
           </a:p>
         </p:txBody>
@@ -1152,10 +893,6 @@
           <a:bodyPr/>
           <a:lstStyle/>
           <a:p>
-            <a:r>
-              <a:rPr lang="en-US" dirty="0"/>
-              <a:t/>
-            </a:r>
             <a:endParaRPr lang="en-US" dirty="0"/>
           </a:p>
         </p:txBody>
@@ -1240,10 +977,6 @@
           <a:bodyPr/>
           <a:lstStyle/>
           <a:p>
-            <a:r>
-              <a:rPr lang="en-US" dirty="0"/>
-              <a:t/>
-            </a:r>
             <a:endParaRPr lang="en-US" dirty="0"/>
           </a:p>
         </p:txBody>
@@ -1328,10 +1061,6 @@
           <a:bodyPr/>
           <a:lstStyle/>
           <a:p>
-            <a:r>
-              <a:rPr lang="en-US" dirty="0"/>
-              <a:t/>
-            </a:r>
             <a:endParaRPr lang="en-US" dirty="0"/>
           </a:p>
         </p:txBody>
@@ -1416,10 +1145,6 @@
           <a:bodyPr/>
           <a:lstStyle/>
           <a:p>
-            <a:r>
-              <a:rPr lang="en-US" dirty="0"/>
-              <a:t/>
-            </a:r>
             <a:endParaRPr lang="en-US" dirty="0"/>
           </a:p>
         </p:txBody>
@@ -1550,7 +1275,7 @@
       <p:pic>
         <p:nvPicPr>
           <p:cNvPr id="4" name="Image 0" descr="preencoded.png">
-            <a:hlinkClick r:id="rId2" tooltip=""/>
+            <a:hlinkClick r:id="rId2"/>
           </p:cNvPr>
           <p:cNvPicPr>
             <a:picLocks noChangeAspect="1"/>
@@ -1558,7 +1283,7 @@
           <p:nvPr/>
         </p:nvPicPr>
         <p:blipFill>
-          <a:blip r:embed="rId1"/>
+          <a:blip r:embed="rId3"/>
           <a:stretch>
             <a:fillRect/>
           </a:stretch>
@@ -1584,6 +1309,11 @@
 <file path=ppt/slideMasters/slideMaster1.xml><?xml version="1.0" encoding="utf-8"?>
 <p:sldMaster xmlns:a="http://schemas.openxmlformats.org/drawingml/2006/main" xmlns:r="http://schemas.openxmlformats.org/officeDocument/2006/relationships" xmlns:p="http://schemas.openxmlformats.org/presentationml/2006/main">
   <p:cSld>
+    <p:bg>
+      <p:bgRef idx="1001">
+        <a:schemeClr val="bg1"/>
+      </p:bgRef>
+    </p:bg>
     <p:spTree>
       <p:nvGrpSpPr>
         <p:cNvPr id="1" name=""/>
@@ -1878,14 +1608,14 @@
       </p:grpSpPr>
       <p:pic>
         <p:nvPicPr>
-          <p:cNvPr id="2" name="Image 0" descr="preencoded.png">    </p:cNvPr>
+          <p:cNvPr id="2" name="Image 0" descr="preencoded.png"/>
           <p:cNvPicPr>
             <a:picLocks noChangeAspect="1"/>
           </p:cNvPicPr>
           <p:nvPr/>
         </p:nvPicPr>
         <p:blipFill>
-          <a:blip r:embed="rId1"/>
+          <a:blip r:embed="rId3"/>
           <a:stretch>
             <a:fillRect/>
           </a:stretch>
@@ -1921,7 +1651,7 @@
           <a:bodyPr wrap="none" lIns="0" tIns="0" rIns="0" bIns="0" rtlCol="0" anchor="t"/>
           <a:lstStyle/>
           <a:p>
-            <a:pPr algn="l" indent="0" marL="0">
+            <a:pPr marL="0" indent="0" algn="l">
               <a:lnSpc>
                 <a:spcPct val="104000"/>
               </a:lnSpc>
@@ -1963,7 +1693,7 @@
           <a:bodyPr wrap="none" lIns="0" tIns="0" rIns="0" bIns="0" rtlCol="0" anchor="t"/>
           <a:lstStyle/>
           <a:p>
-            <a:pPr algn="l" indent="0" marL="0">
+            <a:pPr marL="0" indent="0" algn="l">
               <a:lnSpc>
                 <a:spcPct val="133000"/>
               </a:lnSpc>
@@ -1989,6 +1719,18 @@
   <p:clrMapOvr>
     <a:masterClrMapping/>
   </p:clrMapOvr>
+  <mc:AlternateContent xmlns:mc="http://schemas.openxmlformats.org/markup-compatibility/2006">
+    <mc:Choice xmlns:p14="http://schemas.microsoft.com/office/powerpoint/2010/main" Requires="p14">
+      <p:transition spd="slow" p14:dur="2000">
+        <p14:glitter pattern="hexagon"/>
+      </p:transition>
+    </mc:Choice>
+    <mc:Fallback>
+      <p:transition spd="slow">
+        <p:fade/>
+      </p:transition>
+    </mc:Fallback>
+  </mc:AlternateContent>
 </p:sld>
 </file>
 
@@ -2011,14 +1753,14 @@
       </p:grpSpPr>
       <p:pic>
         <p:nvPicPr>
-          <p:cNvPr id="2" name="Image 0" descr="preencoded.png">    </p:cNvPr>
+          <p:cNvPr id="2" name="Image 0" descr="preencoded.png"/>
           <p:cNvPicPr>
             <a:picLocks noChangeAspect="1"/>
           </p:cNvPicPr>
           <p:nvPr/>
         </p:nvPicPr>
         <p:blipFill>
-          <a:blip r:embed="rId1"/>
+          <a:blip r:embed="rId3"/>
           <a:stretch>
             <a:fillRect/>
           </a:stretch>
@@ -2054,7 +1796,7 @@
           <a:bodyPr wrap="none" lIns="0" tIns="0" rIns="0" bIns="0" rtlCol="0" anchor="t"/>
           <a:lstStyle/>
           <a:p>
-            <a:pPr algn="l" indent="0" marL="0">
+            <a:pPr marL="0" indent="0" algn="l">
               <a:lnSpc>
                 <a:spcPct val="104000"/>
               </a:lnSpc>
@@ -2098,7 +1840,7 @@
           </a:bodyPr>
           <a:lstStyle/>
           <a:p>
-            <a:pPr algn="l" indent="0" marL="0">
+            <a:pPr marL="0" indent="0" algn="l">
               <a:lnSpc>
                 <a:spcPct val="129000"/>
               </a:lnSpc>
@@ -2115,12 +1857,6 @@
               </a:rPr>
               <a:t>Un </a:t>
             </a:r>
-            <a:pPr algn="l" indent="0" marL="0">
-              <a:lnSpc>
-                <a:spcPct val="129000"/>
-              </a:lnSpc>
-              <a:buNone/>
-            </a:pPr>
             <a:r>
               <a:rPr lang="en-US" sz="1350" b="1" dirty="0">
                 <a:solidFill>
@@ -2132,12 +1868,6 @@
               </a:rPr>
               <a:t>ciclo completo de análisis</a:t>
             </a:r>
-            <a:pPr algn="l" indent="0" marL="0">
-              <a:lnSpc>
-                <a:spcPct val="129000"/>
-              </a:lnSpc>
-              <a:buNone/>
-            </a:pPr>
             <a:r>
               <a:rPr lang="en-US" sz="1350" dirty="0">
                 <a:solidFill>
@@ -2155,123 +1885,7 @@
       </p:sp>
       <p:pic>
         <p:nvPicPr>
-          <p:cNvPr id="5" name="Image 1" descr="preencoded.png">    </p:cNvPr>
-          <p:cNvPicPr>
-            <a:picLocks noChangeAspect="1"/>
-          </p:cNvPicPr>
-          <p:nvPr/>
-        </p:nvPicPr>
-        <p:blipFill>
-          <a:blip r:embed="rId2">
-            <a:extLst>
-              <a:ext uri="{96DAC541-7B7A-43D3-8B79-37D633B846F1}">
-                <asvg:svgBlip xmlns:asvg="http://schemas.microsoft.com/office/drawing/2016/SVG/main" r:embed="rId3"/>
-              </a:ext>
-            </a:extLst>
-          </a:blip>
-          <a:stretch>
-            <a:fillRect/>
-          </a:stretch>
-        </p:blipFill>
-        <p:spPr>
-          <a:xfrm>
-            <a:off x="727851" y="2128639"/>
-            <a:ext cx="265800" cy="265807"/>
-          </a:xfrm>
-          <a:prstGeom prst="rect">
-            <a:avLst/>
-          </a:prstGeom>
-        </p:spPr>
-      </p:pic>
-      <p:sp>
-        <p:nvSpPr>
-          <p:cNvPr id="6" name="Text 2"/>
-          <p:cNvSpPr/>
-          <p:nvPr/>
-        </p:nvSpPr>
-        <p:spPr>
-          <a:xfrm>
-            <a:off x="1237326" y="2123182"/>
-            <a:ext cx="5721008" cy="276920"/>
-          </a:xfrm>
-          <a:prstGeom prst="rect">
-            <a:avLst/>
-          </a:prstGeom>
-          <a:noFill/>
-          <a:ln/>
-        </p:spPr>
-        <p:txBody>
-          <a:bodyPr wrap="none" lIns="0" tIns="0" rIns="0" bIns="0" rtlCol="0" anchor="t"/>
-          <a:lstStyle/>
-          <a:p>
-            <a:pPr algn="l" indent="0" marL="0">
-              <a:lnSpc>
-                <a:spcPct val="104000"/>
-              </a:lnSpc>
-              <a:buNone/>
-            </a:pPr>
-            <a:r>
-              <a:rPr lang="en-US" sz="1700" dirty="0">
-                <a:solidFill>
-                  <a:srgbClr val="161613"/>
-                </a:solidFill>
-                <a:latin typeface="DM Sans Medium" pitchFamily="34" charset="0"/>
-                <a:ea typeface="DM Sans Medium" pitchFamily="34" charset="-122"/>
-                <a:cs typeface="DM Sans Medium" pitchFamily="34" charset="-120"/>
-              </a:rPr>
-              <a:t>Datos limpios</a:t>
-            </a:r>
-            <a:endParaRPr lang="en-US" sz="1700" dirty="0"/>
-          </a:p>
-        </p:txBody>
-      </p:sp>
-      <p:sp>
-        <p:nvSpPr>
-          <p:cNvPr id="7" name="Text 3"/>
-          <p:cNvSpPr/>
-          <p:nvPr/>
-        </p:nvSpPr>
-        <p:spPr>
-          <a:xfrm>
-            <a:off x="1237326" y="2499717"/>
-            <a:ext cx="5721008" cy="549275"/>
-          </a:xfrm>
-          <a:prstGeom prst="rect">
-            <a:avLst/>
-          </a:prstGeom>
-          <a:noFill/>
-          <a:ln/>
-        </p:spPr>
-        <p:txBody>
-          <a:bodyPr wrap="square" lIns="0" tIns="0" rIns="0" bIns="0" rtlCol="0" anchor="t">
-            <a:normAutofit/>
-          </a:bodyPr>
-          <a:lstStyle/>
-          <a:p>
-            <a:pPr algn="l" indent="0" marL="0">
-              <a:lnSpc>
-                <a:spcPct val="129000"/>
-              </a:lnSpc>
-              <a:buNone/>
-            </a:pPr>
-            <a:r>
-              <a:rPr lang="en-US" sz="1350" dirty="0">
-                <a:solidFill>
-                  <a:srgbClr val="161613"/>
-                </a:solidFill>
-                <a:latin typeface="Inter" pitchFamily="34" charset="0"/>
-                <a:ea typeface="Inter" pitchFamily="34" charset="-122"/>
-                <a:cs typeface="Inter" pitchFamily="34" charset="-120"/>
-              </a:rPr>
-              <a:t>Integridad del 95,4% garantizada mediante procesos ETL documentados.</a:t>
-            </a:r>
-            <a:endParaRPr lang="en-US" sz="1350" dirty="0"/>
-          </a:p>
-        </p:txBody>
-      </p:sp>
-      <p:pic>
-        <p:nvPicPr>
-          <p:cNvPr id="8" name="Image 2" descr="preencoded.png">    </p:cNvPr>
+          <p:cNvPr id="5" name="Image 1" descr="preencoded.png"/>
           <p:cNvPicPr>
             <a:picLocks noChangeAspect="1"/>
           </p:cNvPicPr>
@@ -2291,7 +1905,7 @@
         </p:blipFill>
         <p:spPr>
           <a:xfrm>
-            <a:off x="727851" y="3386634"/>
+            <a:off x="727851" y="2128639"/>
             <a:ext cx="265800" cy="265807"/>
           </a:xfrm>
           <a:prstGeom prst="rect">
@@ -2301,13 +1915,13 @@
       </p:pic>
       <p:sp>
         <p:nvSpPr>
-          <p:cNvPr id="9" name="Text 4"/>
-          <p:cNvSpPr/>
-          <p:nvPr/>
-        </p:nvSpPr>
-        <p:spPr>
-          <a:xfrm>
-            <a:off x="1237326" y="3381177"/>
+          <p:cNvPr id="6" name="Text 2"/>
+          <p:cNvSpPr/>
+          <p:nvPr/>
+        </p:nvSpPr>
+        <p:spPr>
+          <a:xfrm>
+            <a:off x="1237326" y="2123182"/>
             <a:ext cx="5721008" cy="276920"/>
           </a:xfrm>
           <a:prstGeom prst="rect">
@@ -2320,7 +1934,7 @@
           <a:bodyPr wrap="none" lIns="0" tIns="0" rIns="0" bIns="0" rtlCol="0" anchor="t"/>
           <a:lstStyle/>
           <a:p>
-            <a:pPr algn="l" indent="0" marL="0">
+            <a:pPr marL="0" indent="0" algn="l">
               <a:lnSpc>
                 <a:spcPct val="104000"/>
               </a:lnSpc>
@@ -2335,7 +1949,7 @@
                 <a:ea typeface="DM Sans Medium" pitchFamily="34" charset="-122"/>
                 <a:cs typeface="DM Sans Medium" pitchFamily="34" charset="-120"/>
               </a:rPr>
-              <a:t>KPIs validados</a:t>
+              <a:t>Datos limpios</a:t>
             </a:r>
             <a:endParaRPr lang="en-US" sz="1700" dirty="0"/>
           </a:p>
@@ -2343,26 +1957,28 @@
       </p:sp>
       <p:sp>
         <p:nvSpPr>
-          <p:cNvPr id="10" name="Text 5"/>
-          <p:cNvSpPr/>
-          <p:nvPr/>
-        </p:nvSpPr>
-        <p:spPr>
-          <a:xfrm>
-            <a:off x="1237326" y="3757712"/>
-            <a:ext cx="5721008" cy="274638"/>
-          </a:xfrm>
-          <a:prstGeom prst="rect">
-            <a:avLst/>
-          </a:prstGeom>
-          <a:noFill/>
-          <a:ln/>
-        </p:spPr>
-        <p:txBody>
-          <a:bodyPr wrap="none" lIns="0" tIns="0" rIns="0" bIns="0" rtlCol="0" anchor="t"/>
-          <a:lstStyle/>
-          <a:p>
-            <a:pPr algn="l" indent="0" marL="0">
+          <p:cNvPr id="7" name="Text 3"/>
+          <p:cNvSpPr/>
+          <p:nvPr/>
+        </p:nvSpPr>
+        <p:spPr>
+          <a:xfrm>
+            <a:off x="1237326" y="2499717"/>
+            <a:ext cx="5721008" cy="549275"/>
+          </a:xfrm>
+          <a:prstGeom prst="rect">
+            <a:avLst/>
+          </a:prstGeom>
+          <a:noFill/>
+          <a:ln/>
+        </p:spPr>
+        <p:txBody>
+          <a:bodyPr wrap="square" lIns="0" tIns="0" rIns="0" bIns="0" rtlCol="0" anchor="t">
+            <a:normAutofit/>
+          </a:bodyPr>
+          <a:lstStyle/>
+          <a:p>
+            <a:pPr marL="0" indent="0" algn="l">
               <a:lnSpc>
                 <a:spcPct val="129000"/>
               </a:lnSpc>
@@ -2377,7 +1993,7 @@
                 <a:ea typeface="Inter" pitchFamily="34" charset="-122"/>
                 <a:cs typeface="Inter" pitchFamily="34" charset="-120"/>
               </a:rPr>
-              <a:t>Métricas operativas y financieras auditables y trazables.</a:t>
+              <a:t>Integridad del 95,4% garantizada mediante procesos ETL documentados.</a:t>
             </a:r>
             <a:endParaRPr lang="en-US" sz="1350" dirty="0"/>
           </a:p>
@@ -2385,17 +2001,17 @@
       </p:sp>
       <p:pic>
         <p:nvPicPr>
-          <p:cNvPr id="11" name="Image 3" descr="preencoded.png">    </p:cNvPr>
+          <p:cNvPr id="8" name="Image 2" descr="preencoded.png"/>
           <p:cNvPicPr>
             <a:picLocks noChangeAspect="1"/>
           </p:cNvPicPr>
           <p:nvPr/>
         </p:nvPicPr>
         <p:blipFill>
-          <a:blip r:embed="rId6">
+          <a:blip r:embed="rId4">
             <a:extLst>
               <a:ext uri="{96DAC541-7B7A-43D3-8B79-37D633B846F1}">
-                <asvg:svgBlip xmlns:asvg="http://schemas.microsoft.com/office/drawing/2016/SVG/main" r:embed="rId7"/>
+                <asvg:svgBlip xmlns:asvg="http://schemas.microsoft.com/office/drawing/2016/SVG/main" r:embed="rId5"/>
               </a:ext>
             </a:extLst>
           </a:blip>
@@ -2405,7 +2021,7 @@
         </p:blipFill>
         <p:spPr>
           <a:xfrm>
-            <a:off x="727851" y="4369991"/>
+            <a:off x="727851" y="3386634"/>
             <a:ext cx="265800" cy="265807"/>
           </a:xfrm>
           <a:prstGeom prst="rect">
@@ -2415,13 +2031,13 @@
       </p:pic>
       <p:sp>
         <p:nvSpPr>
-          <p:cNvPr id="12" name="Text 6"/>
-          <p:cNvSpPr/>
-          <p:nvPr/>
-        </p:nvSpPr>
-        <p:spPr>
-          <a:xfrm>
-            <a:off x="1237326" y="4364534"/>
+          <p:cNvPr id="9" name="Text 4"/>
+          <p:cNvSpPr/>
+          <p:nvPr/>
+        </p:nvSpPr>
+        <p:spPr>
+          <a:xfrm>
+            <a:off x="1237326" y="3381177"/>
             <a:ext cx="5721008" cy="276920"/>
           </a:xfrm>
           <a:prstGeom prst="rect">
@@ -2434,7 +2050,7 @@
           <a:bodyPr wrap="none" lIns="0" tIns="0" rIns="0" bIns="0" rtlCol="0" anchor="t"/>
           <a:lstStyle/>
           <a:p>
-            <a:pPr algn="l" indent="0" marL="0">
+            <a:pPr marL="0" indent="0" algn="l">
               <a:lnSpc>
                 <a:spcPct val="104000"/>
               </a:lnSpc>
@@ -2449,7 +2065,7 @@
                 <a:ea typeface="DM Sans Medium" pitchFamily="34" charset="-122"/>
                 <a:cs typeface="DM Sans Medium" pitchFamily="34" charset="-120"/>
               </a:rPr>
-              <a:t>Proyección honesta</a:t>
+              <a:t>KPIs validados</a:t>
             </a:r>
             <a:endParaRPr lang="en-US" sz="1700" dirty="0"/>
           </a:p>
@@ -2457,28 +2073,26 @@
       </p:sp>
       <p:sp>
         <p:nvSpPr>
-          <p:cNvPr id="13" name="Text 7"/>
-          <p:cNvSpPr/>
-          <p:nvPr/>
-        </p:nvSpPr>
-        <p:spPr>
-          <a:xfrm>
-            <a:off x="1237326" y="4741069"/>
-            <a:ext cx="5721008" cy="549275"/>
-          </a:xfrm>
-          <a:prstGeom prst="rect">
-            <a:avLst/>
-          </a:prstGeom>
-          <a:noFill/>
-          <a:ln/>
-        </p:spPr>
-        <p:txBody>
-          <a:bodyPr wrap="square" lIns="0" tIns="0" rIns="0" bIns="0" rtlCol="0" anchor="t">
-            <a:normAutofit/>
-          </a:bodyPr>
-          <a:lstStyle/>
-          <a:p>
-            <a:pPr algn="l" indent="0" marL="0">
+          <p:cNvPr id="10" name="Text 5"/>
+          <p:cNvSpPr/>
+          <p:nvPr/>
+        </p:nvSpPr>
+        <p:spPr>
+          <a:xfrm>
+            <a:off x="1237326" y="3757712"/>
+            <a:ext cx="5721008" cy="274638"/>
+          </a:xfrm>
+          <a:prstGeom prst="rect">
+            <a:avLst/>
+          </a:prstGeom>
+          <a:noFill/>
+          <a:ln/>
+        </p:spPr>
+        <p:txBody>
+          <a:bodyPr wrap="none" lIns="0" tIns="0" rIns="0" bIns="0" rtlCol="0" anchor="t"/>
+          <a:lstStyle/>
+          <a:p>
+            <a:pPr marL="0" indent="0" algn="l">
               <a:lnSpc>
                 <a:spcPct val="129000"/>
               </a:lnSpc>
@@ -2493,7 +2107,7 @@
                 <a:ea typeface="Inter" pitchFamily="34" charset="-122"/>
                 <a:cs typeface="Inter" pitchFamily="34" charset="-120"/>
               </a:rPr>
-              <a:t>Forecast estadístico con margen de error explícito e intervalo de confianza al 95%.</a:t>
+              <a:t>Métricas operativas y financieras auditables y trazables.</a:t>
             </a:r>
             <a:endParaRPr lang="en-US" sz="1350" dirty="0"/>
           </a:p>
@@ -2501,17 +2115,17 @@
       </p:sp>
       <p:pic>
         <p:nvPicPr>
-          <p:cNvPr id="14" name="Image 4" descr="preencoded.png">    </p:cNvPr>
+          <p:cNvPr id="11" name="Image 3" descr="preencoded.png"/>
           <p:cNvPicPr>
             <a:picLocks noChangeAspect="1"/>
           </p:cNvPicPr>
           <p:nvPr/>
         </p:nvPicPr>
         <p:blipFill>
-          <a:blip r:embed="rId8">
+          <a:blip r:embed="rId4">
             <a:extLst>
               <a:ext uri="{96DAC541-7B7A-43D3-8B79-37D633B846F1}">
-                <asvg:svgBlip xmlns:asvg="http://schemas.microsoft.com/office/drawing/2016/SVG/main" r:embed="rId9"/>
+                <asvg:svgBlip xmlns:asvg="http://schemas.microsoft.com/office/drawing/2016/SVG/main" r:embed="rId5"/>
               </a:ext>
             </a:extLst>
           </a:blip>
@@ -2521,7 +2135,7 @@
         </p:blipFill>
         <p:spPr>
           <a:xfrm>
-            <a:off x="727851" y="5627985"/>
+            <a:off x="727851" y="4369991"/>
             <a:ext cx="265800" cy="265807"/>
           </a:xfrm>
           <a:prstGeom prst="rect">
@@ -2531,13 +2145,13 @@
       </p:pic>
       <p:sp>
         <p:nvSpPr>
-          <p:cNvPr id="15" name="Text 8"/>
-          <p:cNvSpPr/>
-          <p:nvPr/>
-        </p:nvSpPr>
-        <p:spPr>
-          <a:xfrm>
-            <a:off x="1237326" y="5622528"/>
+          <p:cNvPr id="12" name="Text 6"/>
+          <p:cNvSpPr/>
+          <p:nvPr/>
+        </p:nvSpPr>
+        <p:spPr>
+          <a:xfrm>
+            <a:off x="1237326" y="4364534"/>
             <a:ext cx="5721008" cy="276920"/>
           </a:xfrm>
           <a:prstGeom prst="rect">
@@ -2550,7 +2164,7 @@
           <a:bodyPr wrap="none" lIns="0" tIns="0" rIns="0" bIns="0" rtlCol="0" anchor="t"/>
           <a:lstStyle/>
           <a:p>
-            <a:pPr algn="l" indent="0" marL="0">
+            <a:pPr marL="0" indent="0" algn="l">
               <a:lnSpc>
                 <a:spcPct val="104000"/>
               </a:lnSpc>
@@ -2565,6 +2179,122 @@
                 <a:ea typeface="DM Sans Medium" pitchFamily="34" charset="-122"/>
                 <a:cs typeface="DM Sans Medium" pitchFamily="34" charset="-120"/>
               </a:rPr>
+              <a:t>Proyección honesta</a:t>
+            </a:r>
+            <a:endParaRPr lang="en-US" sz="1700" dirty="0"/>
+          </a:p>
+        </p:txBody>
+      </p:sp>
+      <p:sp>
+        <p:nvSpPr>
+          <p:cNvPr id="13" name="Text 7"/>
+          <p:cNvSpPr/>
+          <p:nvPr/>
+        </p:nvSpPr>
+        <p:spPr>
+          <a:xfrm>
+            <a:off x="1237326" y="4741069"/>
+            <a:ext cx="5721008" cy="549275"/>
+          </a:xfrm>
+          <a:prstGeom prst="rect">
+            <a:avLst/>
+          </a:prstGeom>
+          <a:noFill/>
+          <a:ln/>
+        </p:spPr>
+        <p:txBody>
+          <a:bodyPr wrap="square" lIns="0" tIns="0" rIns="0" bIns="0" rtlCol="0" anchor="t">
+            <a:normAutofit/>
+          </a:bodyPr>
+          <a:lstStyle/>
+          <a:p>
+            <a:pPr marL="0" indent="0" algn="l">
+              <a:lnSpc>
+                <a:spcPct val="129000"/>
+              </a:lnSpc>
+              <a:buNone/>
+            </a:pPr>
+            <a:r>
+              <a:rPr lang="en-US" sz="1350" dirty="0">
+                <a:solidFill>
+                  <a:srgbClr val="161613"/>
+                </a:solidFill>
+                <a:latin typeface="Inter" pitchFamily="34" charset="0"/>
+                <a:ea typeface="Inter" pitchFamily="34" charset="-122"/>
+                <a:cs typeface="Inter" pitchFamily="34" charset="-120"/>
+              </a:rPr>
+              <a:t>Forecast estadístico con margen de error explícito e intervalo de confianza al 95%.</a:t>
+            </a:r>
+            <a:endParaRPr lang="en-US" sz="1350" dirty="0"/>
+          </a:p>
+        </p:txBody>
+      </p:sp>
+      <p:pic>
+        <p:nvPicPr>
+          <p:cNvPr id="14" name="Image 4" descr="preencoded.png"/>
+          <p:cNvPicPr>
+            <a:picLocks noChangeAspect="1"/>
+          </p:cNvPicPr>
+          <p:nvPr/>
+        </p:nvPicPr>
+        <p:blipFill>
+          <a:blip r:embed="rId4">
+            <a:extLst>
+              <a:ext uri="{96DAC541-7B7A-43D3-8B79-37D633B846F1}">
+                <asvg:svgBlip xmlns:asvg="http://schemas.microsoft.com/office/drawing/2016/SVG/main" r:embed="rId5"/>
+              </a:ext>
+            </a:extLst>
+          </a:blip>
+          <a:stretch>
+            <a:fillRect/>
+          </a:stretch>
+        </p:blipFill>
+        <p:spPr>
+          <a:xfrm>
+            <a:off x="727851" y="5627985"/>
+            <a:ext cx="265800" cy="265807"/>
+          </a:xfrm>
+          <a:prstGeom prst="rect">
+            <a:avLst/>
+          </a:prstGeom>
+        </p:spPr>
+      </p:pic>
+      <p:sp>
+        <p:nvSpPr>
+          <p:cNvPr id="15" name="Text 8"/>
+          <p:cNvSpPr/>
+          <p:nvPr/>
+        </p:nvSpPr>
+        <p:spPr>
+          <a:xfrm>
+            <a:off x="1237326" y="5622528"/>
+            <a:ext cx="5721008" cy="276920"/>
+          </a:xfrm>
+          <a:prstGeom prst="rect">
+            <a:avLst/>
+          </a:prstGeom>
+          <a:noFill/>
+          <a:ln/>
+        </p:spPr>
+        <p:txBody>
+          <a:bodyPr wrap="none" lIns="0" tIns="0" rIns="0" bIns="0" rtlCol="0" anchor="t"/>
+          <a:lstStyle/>
+          <a:p>
+            <a:pPr marL="0" indent="0" algn="l">
+              <a:lnSpc>
+                <a:spcPct val="104000"/>
+              </a:lnSpc>
+              <a:buNone/>
+            </a:pPr>
+            <a:r>
+              <a:rPr lang="en-US" sz="1700" dirty="0">
+                <a:solidFill>
+                  <a:srgbClr val="161613"/>
+                </a:solidFill>
+                <a:latin typeface="DM Sans Medium" pitchFamily="34" charset="0"/>
+                <a:ea typeface="DM Sans Medium" pitchFamily="34" charset="-122"/>
+                <a:cs typeface="DM Sans Medium" pitchFamily="34" charset="-120"/>
+              </a:rPr>
               <a:t>Metodología reproducible</a:t>
             </a:r>
             <a:endParaRPr lang="en-US" sz="1700" dirty="0"/>
@@ -2592,7 +2322,7 @@
           <a:bodyPr wrap="none" lIns="0" tIns="0" rIns="0" bIns="0" rtlCol="0" anchor="t"/>
           <a:lstStyle/>
           <a:p>
-            <a:pPr algn="l" indent="0" marL="0">
+            <a:pPr marL="0" indent="0" algn="l">
               <a:lnSpc>
                 <a:spcPct val="129000"/>
               </a:lnSpc>
@@ -2618,6 +2348,18 @@
   <p:clrMapOvr>
     <a:masterClrMapping/>
   </p:clrMapOvr>
+  <mc:AlternateContent xmlns:mc="http://schemas.openxmlformats.org/markup-compatibility/2006">
+    <mc:Choice xmlns:p14="http://schemas.microsoft.com/office/powerpoint/2010/main" Requires="p14">
+      <p:transition spd="slow" p14:dur="1200">
+        <p14:prism/>
+      </p:transition>
+    </mc:Choice>
+    <mc:Fallback>
+      <p:transition spd="slow">
+        <p:fade/>
+      </p:transition>
+    </mc:Fallback>
+  </mc:AlternateContent>
 </p:sld>
 </file>
 
@@ -2659,7 +2401,7 @@
           <a:bodyPr wrap="none" lIns="0" tIns="0" rIns="0" bIns="0" rtlCol="0" anchor="t"/>
           <a:lstStyle/>
           <a:p>
-            <a:pPr algn="l" indent="0" marL="0">
+            <a:pPr marL="0" indent="0" algn="l">
               <a:lnSpc>
                 <a:spcPct val="104000"/>
               </a:lnSpc>
@@ -2682,159 +2424,7 @@
       </p:sp>
       <p:pic>
         <p:nvPicPr>
-          <p:cNvPr id="3" name="Image 0" descr="preencoded.png">    </p:cNvPr>
-          <p:cNvPicPr>
-            <a:picLocks noChangeAspect="1"/>
-          </p:cNvPicPr>
-          <p:nvPr/>
-        </p:nvPicPr>
-        <p:blipFill>
-          <a:blip r:embed="rId1">
-            <a:extLst>
-              <a:ext uri="{96DAC541-7B7A-43D3-8B79-37D633B846F1}">
-                <asvg:svgBlip xmlns:asvg="http://schemas.microsoft.com/office/drawing/2016/SVG/main" r:embed="rId2"/>
-              </a:ext>
-            </a:extLst>
-          </a:blip>
-          <a:stretch>
-            <a:fillRect/>
-          </a:stretch>
-        </p:blipFill>
-        <p:spPr>
-          <a:xfrm>
-            <a:off x="661475" y="2849563"/>
-            <a:ext cx="3496877" cy="2032893"/>
-          </a:xfrm>
-          <a:prstGeom prst="rect">
-            <a:avLst/>
-          </a:prstGeom>
-        </p:spPr>
-      </p:pic>
-      <p:sp>
-        <p:nvSpPr>
-          <p:cNvPr id="4" name="Text 1"/>
-          <p:cNvSpPr/>
-          <p:nvPr/>
-        </p:nvSpPr>
-        <p:spPr>
-          <a:xfrm>
-            <a:off x="977479" y="3063974"/>
-            <a:ext cx="2966467" cy="885825"/>
-          </a:xfrm>
-          <a:prstGeom prst="rect">
-            <a:avLst/>
-          </a:prstGeom>
-          <a:noFill/>
-          <a:ln/>
-        </p:spPr>
-        <p:txBody>
-          <a:bodyPr wrap="square" lIns="0" tIns="0" rIns="0" bIns="0" rtlCol="0" anchor="t">
-            <a:normAutofit/>
-          </a:bodyPr>
-          <a:lstStyle/>
-          <a:p>
-            <a:pPr algn="l" indent="0" marL="0">
-              <a:lnSpc>
-                <a:spcPct val="104000"/>
-              </a:lnSpc>
-              <a:buNone/>
-            </a:pPr>
-            <a:r>
-              <a:rPr lang="en-US" sz="1850" dirty="0">
-                <a:solidFill>
-                  <a:srgbClr val="161613"/>
-                </a:solidFill>
-                <a:latin typeface="DM Sans Medium" pitchFamily="34" charset="0"/>
-                <a:ea typeface="DM Sans Medium" pitchFamily="34" charset="-122"/>
-                <a:cs typeface="DM Sans Medium" pitchFamily="34" charset="-120"/>
-              </a:rPr>
-              <a:t>Priorizar la inversión en Servicios de Valor Añadido / Cloud</a:t>
-            </a:r>
-            <a:endParaRPr lang="en-US" sz="1850" dirty="0"/>
-          </a:p>
-        </p:txBody>
-      </p:sp>
-      <p:sp>
-        <p:nvSpPr>
-          <p:cNvPr id="5" name="Text 2"/>
-          <p:cNvSpPr/>
-          <p:nvPr/>
-        </p:nvSpPr>
-        <p:spPr>
-          <a:xfrm>
-            <a:off x="977479" y="4063206"/>
-            <a:ext cx="2966467" cy="604838"/>
-          </a:xfrm>
-          <a:prstGeom prst="rect">
-            <a:avLst/>
-          </a:prstGeom>
-          <a:noFill/>
-          <a:ln/>
-        </p:spPr>
-        <p:txBody>
-          <a:bodyPr wrap="square" lIns="0" tIns="0" rIns="0" bIns="0" rtlCol="0" anchor="t">
-            <a:normAutofit/>
-          </a:bodyPr>
-          <a:lstStyle/>
-          <a:p>
-            <a:pPr algn="l" indent="0" marL="0">
-              <a:lnSpc>
-                <a:spcPct val="133000"/>
-              </a:lnSpc>
-              <a:buNone/>
-            </a:pPr>
-            <a:r>
-              <a:rPr lang="en-US" sz="1450" dirty="0">
-                <a:solidFill>
-                  <a:srgbClr val="161613"/>
-                </a:solidFill>
-                <a:latin typeface="Inter" pitchFamily="34" charset="0"/>
-                <a:ea typeface="Inter" pitchFamily="34" charset="-122"/>
-                <a:cs typeface="Inter" pitchFamily="34" charset="-120"/>
-              </a:rPr>
-              <a:t>La línea de mayor crecimiento — </a:t>
-            </a:r>
-            <a:pPr algn="l" indent="0" marL="0">
-              <a:lnSpc>
-                <a:spcPct val="133000"/>
-              </a:lnSpc>
-              <a:buNone/>
-            </a:pPr>
-            <a:r>
-              <a:rPr lang="en-US" sz="1450" b="1" dirty="0">
-                <a:solidFill>
-                  <a:srgbClr val="161613"/>
-                </a:solidFill>
-                <a:latin typeface="Inter Bold" pitchFamily="34" charset="0"/>
-                <a:ea typeface="Inter Bold" pitchFamily="34" charset="-122"/>
-                <a:cs typeface="Inter Bold" pitchFamily="34" charset="-120"/>
-              </a:rPr>
-              <a:t>+37,8%</a:t>
-            </a:r>
-            <a:pPr algn="l" indent="0" marL="0">
-              <a:lnSpc>
-                <a:spcPct val="133000"/>
-              </a:lnSpc>
-              <a:buNone/>
-            </a:pPr>
-            <a:r>
-              <a:rPr lang="en-US" sz="1450" dirty="0">
-                <a:solidFill>
-                  <a:srgbClr val="161613"/>
-                </a:solidFill>
-                <a:latin typeface="Inter" pitchFamily="34" charset="0"/>
-                <a:ea typeface="Inter" pitchFamily="34" charset="-122"/>
-                <a:cs typeface="Inter" pitchFamily="34" charset="-120"/>
-              </a:rPr>
-              <a:t> en 2025.</a:t>
-            </a:r>
-            <a:endParaRPr lang="en-US" sz="1450" dirty="0"/>
-          </a:p>
-        </p:txBody>
-      </p:sp>
-      <p:pic>
-        <p:nvPicPr>
-          <p:cNvPr id="6" name="Image 1" descr="preencoded.png">    </p:cNvPr>
+          <p:cNvPr id="3" name="Image 0" descr="preencoded.png"/>
           <p:cNvPicPr>
             <a:picLocks noChangeAspect="1"/>
           </p:cNvPicPr>
@@ -2854,7 +2444,7 @@
         </p:blipFill>
         <p:spPr>
           <a:xfrm>
-            <a:off x="4347359" y="2849563"/>
+            <a:off x="661475" y="2849563"/>
             <a:ext cx="3496877" cy="2032893"/>
           </a:xfrm>
           <a:prstGeom prst="rect">
@@ -2864,13 +2454,13 @@
       </p:pic>
       <p:sp>
         <p:nvSpPr>
-          <p:cNvPr id="7" name="Text 3"/>
-          <p:cNvSpPr/>
-          <p:nvPr/>
-        </p:nvSpPr>
-        <p:spPr>
-          <a:xfrm>
-            <a:off x="4663363" y="3063974"/>
+          <p:cNvPr id="4" name="Text 1"/>
+          <p:cNvSpPr/>
+          <p:nvPr/>
+        </p:nvSpPr>
+        <p:spPr>
+          <a:xfrm>
+            <a:off x="977479" y="3063974"/>
             <a:ext cx="2966467" cy="885825"/>
           </a:xfrm>
           <a:prstGeom prst="rect">
@@ -2885,7 +2475,7 @@
           </a:bodyPr>
           <a:lstStyle/>
           <a:p>
-            <a:pPr algn="l" indent="0" marL="0">
+            <a:pPr marL="0" indent="0" algn="l">
               <a:lnSpc>
                 <a:spcPct val="104000"/>
               </a:lnSpc>
@@ -2900,7 +2490,7 @@
                 <a:ea typeface="DM Sans Medium" pitchFamily="34" charset="-122"/>
                 <a:cs typeface="DM Sans Medium" pitchFamily="34" charset="-120"/>
               </a:rPr>
-              <a:t>Formalizar el control mensual en Marketing y Tecnología y TI</a:t>
+              <a:t>Priorizar la inversión en Servicios de Valor Añadido / Cloud</a:t>
             </a:r>
             <a:endParaRPr lang="en-US" sz="1850" dirty="0"/>
           </a:p>
@@ -2908,13 +2498,13 @@
       </p:sp>
       <p:sp>
         <p:nvSpPr>
-          <p:cNvPr id="8" name="Text 4"/>
-          <p:cNvSpPr/>
-          <p:nvPr/>
-        </p:nvSpPr>
-        <p:spPr>
-          <a:xfrm>
-            <a:off x="4663363" y="4063206"/>
+          <p:cNvPr id="5" name="Text 2"/>
+          <p:cNvSpPr/>
+          <p:nvPr/>
+        </p:nvSpPr>
+        <p:spPr>
+          <a:xfrm>
+            <a:off x="977479" y="4063206"/>
             <a:ext cx="2966467" cy="604838"/>
           </a:xfrm>
           <a:prstGeom prst="rect">
@@ -2929,12 +2519,23 @@
           </a:bodyPr>
           <a:lstStyle/>
           <a:p>
-            <a:pPr algn="l" indent="0" marL="0">
+            <a:pPr marL="0" indent="0" algn="l">
               <a:lnSpc>
                 <a:spcPct val="133000"/>
               </a:lnSpc>
               <a:buNone/>
             </a:pPr>
+            <a:r>
+              <a:rPr lang="en-US" sz="1450" dirty="0">
+                <a:solidFill>
+                  <a:srgbClr val="161613"/>
+                </a:solidFill>
+                <a:latin typeface="Inter" pitchFamily="34" charset="0"/>
+                <a:ea typeface="Inter" pitchFamily="34" charset="-122"/>
+                <a:cs typeface="Inter" pitchFamily="34" charset="-120"/>
+              </a:rPr>
+              <a:t>La línea de mayor crecimiento — </a:t>
+            </a:r>
             <a:r>
               <a:rPr lang="en-US" sz="1450" b="1" dirty="0">
                 <a:solidFill>
@@ -2944,14 +2545,8 @@
                 <a:ea typeface="Inter Bold" pitchFamily="34" charset="-122"/>
                 <a:cs typeface="Inter Bold" pitchFamily="34" charset="-120"/>
               </a:rPr>
-              <a:t>15 alertas</a:t>
-            </a:r>
-            <a:pPr algn="l" indent="0" marL="0">
-              <a:lnSpc>
-                <a:spcPct val="133000"/>
-              </a:lnSpc>
-              <a:buNone/>
-            </a:pPr>
+              <a:t>+37,8%</a:t>
+            </a:r>
             <a:r>
               <a:rPr lang="en-US" sz="1450" dirty="0">
                 <a:solidFill>
@@ -2961,7 +2556,7 @@
                 <a:ea typeface="Inter" pitchFamily="34" charset="-122"/>
                 <a:cs typeface="Inter" pitchFamily="34" charset="-120"/>
               </a:rPr>
-              <a:t> de sobreejecución (&gt;10%) detectadas en 2025.</a:t>
+              <a:t> en 2025.</a:t>
             </a:r>
             <a:endParaRPr lang="en-US" sz="1450" dirty="0"/>
           </a:p>
@@ -2969,17 +2564,17 @@
       </p:sp>
       <p:pic>
         <p:nvPicPr>
-          <p:cNvPr id="9" name="Image 2" descr="preencoded.png">    </p:cNvPr>
+          <p:cNvPr id="6" name="Image 1" descr="preencoded.png"/>
           <p:cNvPicPr>
             <a:picLocks noChangeAspect="1"/>
           </p:cNvPicPr>
           <p:nvPr/>
         </p:nvPicPr>
         <p:blipFill>
-          <a:blip r:embed="rId5">
+          <a:blip r:embed="rId3">
             <a:extLst>
               <a:ext uri="{96DAC541-7B7A-43D3-8B79-37D633B846F1}">
-                <asvg:svgBlip xmlns:asvg="http://schemas.microsoft.com/office/drawing/2016/SVG/main" r:embed="rId6"/>
+                <asvg:svgBlip xmlns:asvg="http://schemas.microsoft.com/office/drawing/2016/SVG/main" r:embed="rId4"/>
               </a:ext>
             </a:extLst>
           </a:blip>
@@ -2989,7 +2584,7 @@
         </p:blipFill>
         <p:spPr>
           <a:xfrm>
-            <a:off x="8033244" y="2849563"/>
+            <a:off x="4347359" y="2849563"/>
             <a:ext cx="3496877" cy="2032893"/>
           </a:xfrm>
           <a:prstGeom prst="rect">
@@ -2999,13 +2594,13 @@
       </p:pic>
       <p:sp>
         <p:nvSpPr>
-          <p:cNvPr id="10" name="Text 5"/>
-          <p:cNvSpPr/>
-          <p:nvPr/>
-        </p:nvSpPr>
-        <p:spPr>
-          <a:xfrm>
-            <a:off x="8349247" y="3063974"/>
+          <p:cNvPr id="7" name="Text 3"/>
+          <p:cNvSpPr/>
+          <p:nvPr/>
+        </p:nvSpPr>
+        <p:spPr>
+          <a:xfrm>
+            <a:off x="4663363" y="3063974"/>
             <a:ext cx="2966467" cy="885825"/>
           </a:xfrm>
           <a:prstGeom prst="rect">
@@ -3020,7 +2615,7 @@
           </a:bodyPr>
           <a:lstStyle/>
           <a:p>
-            <a:pPr algn="l" indent="0" marL="0">
+            <a:pPr marL="0" indent="0" algn="l">
               <a:lnSpc>
                 <a:spcPct val="104000"/>
               </a:lnSpc>
@@ -3035,7 +2630,7 @@
                 <a:ea typeface="DM Sans Medium" pitchFamily="34" charset="-122"/>
                 <a:cs typeface="DM Sans Medium" pitchFamily="34" charset="-120"/>
               </a:rPr>
-              <a:t>Reinvertir el margen proyectado en el crecimiento</a:t>
+              <a:t>Formalizar el control mensual en Marketing y Tecnología y TI</a:t>
             </a:r>
             <a:endParaRPr lang="en-US" sz="1850" dirty="0"/>
           </a:p>
@@ -3043,13 +2638,13 @@
       </p:sp>
       <p:sp>
         <p:nvSpPr>
-          <p:cNvPr id="11" name="Text 6"/>
-          <p:cNvSpPr/>
-          <p:nvPr/>
-        </p:nvSpPr>
-        <p:spPr>
-          <a:xfrm>
-            <a:off x="8349247" y="4063206"/>
+          <p:cNvPr id="8" name="Text 4"/>
+          <p:cNvSpPr/>
+          <p:nvPr/>
+        </p:nvSpPr>
+        <p:spPr>
+          <a:xfrm>
+            <a:off x="4663363" y="4063206"/>
             <a:ext cx="2966467" cy="604838"/>
           </a:xfrm>
           <a:prstGeom prst="rect">
@@ -3064,12 +2659,23 @@
           </a:bodyPr>
           <a:lstStyle/>
           <a:p>
-            <a:pPr algn="l" indent="0" marL="0">
+            <a:pPr marL="0" indent="0" algn="l">
               <a:lnSpc>
                 <a:spcPct val="133000"/>
               </a:lnSpc>
               <a:buNone/>
             </a:pPr>
+            <a:r>
+              <a:rPr lang="en-US" sz="1450" b="1" dirty="0">
+                <a:solidFill>
+                  <a:srgbClr val="161613"/>
+                </a:solidFill>
+                <a:latin typeface="Inter Bold" pitchFamily="34" charset="0"/>
+                <a:ea typeface="Inter Bold" pitchFamily="34" charset="-122"/>
+                <a:cs typeface="Inter Bold" pitchFamily="34" charset="-120"/>
+              </a:rPr>
+              <a:t>15 alertas</a:t>
+            </a:r>
             <a:r>
               <a:rPr lang="en-US" sz="1450" dirty="0">
                 <a:solidFill>
@@ -3079,14 +2685,126 @@
                 <a:ea typeface="Inter" pitchFamily="34" charset="-122"/>
                 <a:cs typeface="Inter" pitchFamily="34" charset="-120"/>
               </a:rPr>
+              <a:t> de sobreejecución (&gt;10%) detectadas en 2025.</a:t>
+            </a:r>
+            <a:endParaRPr lang="en-US" sz="1450" dirty="0"/>
+          </a:p>
+        </p:txBody>
+      </p:sp>
+      <p:pic>
+        <p:nvPicPr>
+          <p:cNvPr id="9" name="Image 2" descr="preencoded.png"/>
+          <p:cNvPicPr>
+            <a:picLocks noChangeAspect="1"/>
+          </p:cNvPicPr>
+          <p:nvPr/>
+        </p:nvPicPr>
+        <p:blipFill>
+          <a:blip r:embed="rId3">
+            <a:extLst>
+              <a:ext uri="{96DAC541-7B7A-43D3-8B79-37D633B846F1}">
+                <asvg:svgBlip xmlns:asvg="http://schemas.microsoft.com/office/drawing/2016/SVG/main" r:embed="rId4"/>
+              </a:ext>
+            </a:extLst>
+          </a:blip>
+          <a:stretch>
+            <a:fillRect/>
+          </a:stretch>
+        </p:blipFill>
+        <p:spPr>
+          <a:xfrm>
+            <a:off x="8033244" y="2849563"/>
+            <a:ext cx="3496877" cy="2032893"/>
+          </a:xfrm>
+          <a:prstGeom prst="rect">
+            <a:avLst/>
+          </a:prstGeom>
+        </p:spPr>
+      </p:pic>
+      <p:sp>
+        <p:nvSpPr>
+          <p:cNvPr id="10" name="Text 5"/>
+          <p:cNvSpPr/>
+          <p:nvPr/>
+        </p:nvSpPr>
+        <p:spPr>
+          <a:xfrm>
+            <a:off x="8349247" y="3063974"/>
+            <a:ext cx="2966467" cy="885825"/>
+          </a:xfrm>
+          <a:prstGeom prst="rect">
+            <a:avLst/>
+          </a:prstGeom>
+          <a:noFill/>
+          <a:ln/>
+        </p:spPr>
+        <p:txBody>
+          <a:bodyPr wrap="square" lIns="0" tIns="0" rIns="0" bIns="0" rtlCol="0" anchor="t">
+            <a:normAutofit/>
+          </a:bodyPr>
+          <a:lstStyle/>
+          <a:p>
+            <a:pPr marL="0" indent="0" algn="l">
+              <a:lnSpc>
+                <a:spcPct val="104000"/>
+              </a:lnSpc>
+              <a:buNone/>
+            </a:pPr>
+            <a:r>
+              <a:rPr lang="en-US" sz="1850" dirty="0">
+                <a:solidFill>
+                  <a:srgbClr val="161613"/>
+                </a:solidFill>
+                <a:latin typeface="DM Sans Medium" pitchFamily="34" charset="0"/>
+                <a:ea typeface="DM Sans Medium" pitchFamily="34" charset="-122"/>
+                <a:cs typeface="DM Sans Medium" pitchFamily="34" charset="-120"/>
+              </a:rPr>
+              <a:t>Reinvertir el margen proyectado en el crecimiento</a:t>
+            </a:r>
+            <a:endParaRPr lang="en-US" sz="1850" dirty="0"/>
+          </a:p>
+        </p:txBody>
+      </p:sp>
+      <p:sp>
+        <p:nvSpPr>
+          <p:cNvPr id="11" name="Text 6"/>
+          <p:cNvSpPr/>
+          <p:nvPr/>
+        </p:nvSpPr>
+        <p:spPr>
+          <a:xfrm>
+            <a:off x="8349247" y="4063206"/>
+            <a:ext cx="2966467" cy="604838"/>
+          </a:xfrm>
+          <a:prstGeom prst="rect">
+            <a:avLst/>
+          </a:prstGeom>
+          <a:noFill/>
+          <a:ln/>
+        </p:spPr>
+        <p:txBody>
+          <a:bodyPr wrap="square" lIns="0" tIns="0" rIns="0" bIns="0" rtlCol="0" anchor="t">
+            <a:normAutofit/>
+          </a:bodyPr>
+          <a:lstStyle/>
+          <a:p>
+            <a:pPr marL="0" indent="0" algn="l">
+              <a:lnSpc>
+                <a:spcPct val="133000"/>
+              </a:lnSpc>
+              <a:buNone/>
+            </a:pPr>
+            <a:r>
+              <a:rPr lang="en-US" sz="1450" dirty="0">
+                <a:solidFill>
+                  <a:srgbClr val="161613"/>
+                </a:solidFill>
+                <a:latin typeface="Inter" pitchFamily="34" charset="0"/>
+                <a:ea typeface="Inter" pitchFamily="34" charset="-122"/>
+                <a:cs typeface="Inter" pitchFamily="34" charset="-120"/>
+              </a:rPr>
               <a:t>Margen esperado 2026: </a:t>
             </a:r>
-            <a:pPr algn="l" indent="0" marL="0">
-              <a:lnSpc>
-                <a:spcPct val="133000"/>
-              </a:lnSpc>
-              <a:buNone/>
-            </a:pPr>
             <a:r>
               <a:rPr lang="en-US" sz="1450" b="1" dirty="0">
                 <a:solidFill>
@@ -3098,12 +2816,6 @@
               </a:rPr>
               <a:t>34,2%</a:t>
             </a:r>
-            <a:pPr algn="l" indent="0" marL="0">
-              <a:lnSpc>
-                <a:spcPct val="133000"/>
-              </a:lnSpc>
-              <a:buNone/>
-            </a:pPr>
             <a:r>
               <a:rPr lang="en-US" sz="1450" dirty="0">
                 <a:solidFill>
@@ -3115,12 +2827,6 @@
               </a:rPr>
               <a:t> (</a:t>
             </a:r>
-            <a:pPr algn="l" indent="0" marL="0">
-              <a:lnSpc>
-                <a:spcPct val="133000"/>
-              </a:lnSpc>
-              <a:buNone/>
-            </a:pPr>
             <a:r>
               <a:rPr lang="en-US" sz="1450" b="1" dirty="0">
                 <a:solidFill>
@@ -3132,12 +2838,6 @@
               </a:rPr>
               <a:t>+4,9 p.p.</a:t>
             </a:r>
-            <a:pPr algn="l" indent="0" marL="0">
-              <a:lnSpc>
-                <a:spcPct val="133000"/>
-              </a:lnSpc>
-              <a:buNone/>
-            </a:pPr>
             <a:r>
               <a:rPr lang="en-US" sz="1450" dirty="0">
                 <a:solidFill>
@@ -3158,6 +2858,18 @@
   <p:clrMapOvr>
     <a:masterClrMapping/>
   </p:clrMapOvr>
+  <mc:AlternateContent xmlns:mc="http://schemas.openxmlformats.org/markup-compatibility/2006">
+    <mc:Choice xmlns:p14="http://schemas.microsoft.com/office/powerpoint/2010/main" Requires="p14">
+      <p:transition spd="slow" p14:dur="1200">
+        <p14:prism/>
+      </p:transition>
+    </mc:Choice>
+    <mc:Fallback>
+      <p:transition spd="slow">
+        <p:fade/>
+      </p:transition>
+    </mc:Fallback>
+  </mc:AlternateContent>
 </p:sld>
 </file>
 
@@ -3199,7 +2911,7 @@
           <a:bodyPr wrap="none" lIns="0" tIns="0" rIns="0" bIns="0" rtlCol="0" anchor="t"/>
           <a:lstStyle/>
           <a:p>
-            <a:pPr algn="l" indent="0" marL="0">
+            <a:pPr marL="0" indent="0" algn="l">
               <a:lnSpc>
                 <a:spcPct val="104000"/>
               </a:lnSpc>
@@ -3241,7 +2953,7 @@
           <a:bodyPr wrap="none" lIns="0" tIns="0" rIns="0" bIns="0" rtlCol="0" anchor="ctr"/>
           <a:lstStyle/>
           <a:p>
-            <a:pPr algn="l" indent="0" marL="0">
+            <a:pPr marL="0" indent="0" algn="l">
               <a:lnSpc>
                 <a:spcPct val="100000"/>
               </a:lnSpc>
@@ -3281,6 +2993,13 @@
           </a:solidFill>
           <a:ln/>
         </p:spPr>
+        <p:txBody>
+          <a:bodyPr/>
+          <a:lstStyle/>
+          <a:p>
+            <a:endParaRPr lang="es-VE"/>
+          </a:p>
+        </p:txBody>
       </p:sp>
       <p:sp>
         <p:nvSpPr>
@@ -3303,7 +3022,7 @@
           <a:bodyPr wrap="none" lIns="0" tIns="0" rIns="0" bIns="0" rtlCol="0" anchor="t"/>
           <a:lstStyle/>
           <a:p>
-            <a:pPr algn="l" indent="0" marL="0">
+            <a:pPr marL="0" indent="0" algn="l">
               <a:lnSpc>
                 <a:spcPct val="104000"/>
               </a:lnSpc>
@@ -3345,7 +3064,7 @@
           <a:bodyPr wrap="none" lIns="0" tIns="0" rIns="0" bIns="0" rtlCol="0" anchor="ctr"/>
           <a:lstStyle/>
           <a:p>
-            <a:pPr algn="l" indent="0" marL="0">
+            <a:pPr marL="0" indent="0" algn="l">
               <a:lnSpc>
                 <a:spcPct val="100000"/>
               </a:lnSpc>
@@ -3385,6 +3104,13 @@
           </a:solidFill>
           <a:ln/>
         </p:spPr>
+        <p:txBody>
+          <a:bodyPr/>
+          <a:lstStyle/>
+          <a:p>
+            <a:endParaRPr lang="es-VE"/>
+          </a:p>
+        </p:txBody>
       </p:sp>
       <p:sp>
         <p:nvSpPr>
@@ -3407,7 +3133,7 @@
           <a:bodyPr wrap="none" lIns="0" tIns="0" rIns="0" bIns="0" rtlCol="0" anchor="t"/>
           <a:lstStyle/>
           <a:p>
-            <a:pPr algn="l" indent="0" marL="0">
+            <a:pPr marL="0" indent="0" algn="l">
               <a:lnSpc>
                 <a:spcPct val="104000"/>
               </a:lnSpc>
@@ -3449,7 +3175,7 @@
           <a:bodyPr wrap="none" lIns="0" tIns="0" rIns="0" bIns="0" rtlCol="0" anchor="ctr"/>
           <a:lstStyle/>
           <a:p>
-            <a:pPr algn="l" indent="0" marL="0">
+            <a:pPr marL="0" indent="0" algn="l">
               <a:lnSpc>
                 <a:spcPct val="100000"/>
               </a:lnSpc>
@@ -3489,6 +3215,13 @@
           </a:solidFill>
           <a:ln/>
         </p:spPr>
+        <p:txBody>
+          <a:bodyPr/>
+          <a:lstStyle/>
+          <a:p>
+            <a:endParaRPr lang="es-VE"/>
+          </a:p>
+        </p:txBody>
       </p:sp>
       <p:sp>
         <p:nvSpPr>
@@ -3511,7 +3244,7 @@
           <a:bodyPr wrap="none" lIns="0" tIns="0" rIns="0" bIns="0" rtlCol="0" anchor="t"/>
           <a:lstStyle/>
           <a:p>
-            <a:pPr algn="l" indent="0" marL="0">
+            <a:pPr marL="0" indent="0" algn="l">
               <a:lnSpc>
                 <a:spcPct val="104000"/>
               </a:lnSpc>
@@ -3553,7 +3286,7 @@
           <a:bodyPr wrap="none" lIns="0" tIns="0" rIns="0" bIns="0" rtlCol="0" anchor="ctr"/>
           <a:lstStyle/>
           <a:p>
-            <a:pPr algn="l" indent="0" marL="0">
+            <a:pPr marL="0" indent="0" algn="l">
               <a:lnSpc>
                 <a:spcPct val="100000"/>
               </a:lnSpc>
@@ -3593,6 +3326,13 @@
           </a:solidFill>
           <a:ln/>
         </p:spPr>
+        <p:txBody>
+          <a:bodyPr/>
+          <a:lstStyle/>
+          <a:p>
+            <a:endParaRPr lang="es-VE"/>
+          </a:p>
+        </p:txBody>
       </p:sp>
       <p:sp>
         <p:nvSpPr>
@@ -3615,7 +3355,7 @@
           <a:bodyPr wrap="none" lIns="0" tIns="0" rIns="0" bIns="0" rtlCol="0" anchor="t"/>
           <a:lstStyle/>
           <a:p>
-            <a:pPr algn="l" indent="0" marL="0">
+            <a:pPr marL="0" indent="0" algn="l">
               <a:lnSpc>
                 <a:spcPct val="104000"/>
               </a:lnSpc>
@@ -3657,7 +3397,7 @@
           <a:bodyPr wrap="none" lIns="0" tIns="0" rIns="0" bIns="0" rtlCol="0" anchor="ctr"/>
           <a:lstStyle/>
           <a:p>
-            <a:pPr algn="l" indent="0" marL="0">
+            <a:pPr marL="0" indent="0" algn="l">
               <a:lnSpc>
                 <a:spcPct val="100000"/>
               </a:lnSpc>
@@ -3697,6 +3437,13 @@
           </a:solidFill>
           <a:ln/>
         </p:spPr>
+        <p:txBody>
+          <a:bodyPr/>
+          <a:lstStyle/>
+          <a:p>
+            <a:endParaRPr lang="es-VE"/>
+          </a:p>
+        </p:txBody>
       </p:sp>
       <p:sp>
         <p:nvSpPr>
@@ -3719,7 +3466,7 @@
           <a:bodyPr wrap="none" lIns="0" tIns="0" rIns="0" bIns="0" rtlCol="0" anchor="t"/>
           <a:lstStyle/>
           <a:p>
-            <a:pPr algn="l" indent="0" marL="0">
+            <a:pPr marL="0" indent="0" algn="l">
               <a:lnSpc>
                 <a:spcPct val="104000"/>
               </a:lnSpc>
@@ -3761,7 +3508,7 @@
           <a:bodyPr wrap="none" lIns="0" tIns="0" rIns="0" bIns="0" rtlCol="0" anchor="ctr"/>
           <a:lstStyle/>
           <a:p>
-            <a:pPr algn="l" indent="0" marL="0">
+            <a:pPr marL="0" indent="0" algn="l">
               <a:lnSpc>
                 <a:spcPct val="100000"/>
               </a:lnSpc>
@@ -3801,6 +3548,13 @@
           </a:solidFill>
           <a:ln/>
         </p:spPr>
+        <p:txBody>
+          <a:bodyPr/>
+          <a:lstStyle/>
+          <a:p>
+            <a:endParaRPr lang="es-VE"/>
+          </a:p>
+        </p:txBody>
       </p:sp>
       <p:sp>
         <p:nvSpPr>
@@ -3823,7 +3577,7 @@
           <a:bodyPr wrap="none" lIns="0" tIns="0" rIns="0" bIns="0" rtlCol="0" anchor="t"/>
           <a:lstStyle/>
           <a:p>
-            <a:pPr algn="l" indent="0" marL="0">
+            <a:pPr marL="0" indent="0" algn="l">
               <a:lnSpc>
                 <a:spcPct val="104000"/>
               </a:lnSpc>
@@ -3865,7 +3619,7 @@
           <a:bodyPr wrap="none" lIns="0" tIns="0" rIns="0" bIns="0" rtlCol="0" anchor="ctr"/>
           <a:lstStyle/>
           <a:p>
-            <a:pPr algn="l" indent="0" marL="0">
+            <a:pPr marL="0" indent="0" algn="l">
               <a:lnSpc>
                 <a:spcPct val="100000"/>
               </a:lnSpc>
@@ -3905,6 +3659,13 @@
           </a:solidFill>
           <a:ln/>
         </p:spPr>
+        <p:txBody>
+          <a:bodyPr/>
+          <a:lstStyle/>
+          <a:p>
+            <a:endParaRPr lang="es-VE"/>
+          </a:p>
+        </p:txBody>
       </p:sp>
       <p:sp>
         <p:nvSpPr>
@@ -3929,7 +3690,7 @@
           </a:bodyPr>
           <a:lstStyle/>
           <a:p>
-            <a:pPr algn="l" indent="0" marL="0">
+            <a:pPr marL="0" indent="0" algn="l">
               <a:lnSpc>
                 <a:spcPct val="104000"/>
               </a:lnSpc>
@@ -3971,7 +3732,7 @@
           <a:bodyPr wrap="none" lIns="0" tIns="0" rIns="0" bIns="0" rtlCol="0" anchor="ctr"/>
           <a:lstStyle/>
           <a:p>
-            <a:pPr algn="l" indent="0" marL="0">
+            <a:pPr marL="0" indent="0" algn="l">
               <a:lnSpc>
                 <a:spcPct val="100000"/>
               </a:lnSpc>
@@ -4011,6 +3772,13 @@
           </a:solidFill>
           <a:ln/>
         </p:spPr>
+        <p:txBody>
+          <a:bodyPr/>
+          <a:lstStyle/>
+          <a:p>
+            <a:endParaRPr lang="es-VE"/>
+          </a:p>
+        </p:txBody>
       </p:sp>
       <p:sp>
         <p:nvSpPr>
@@ -4033,7 +3801,7 @@
           <a:bodyPr wrap="none" lIns="0" tIns="0" rIns="0" bIns="0" rtlCol="0" anchor="t"/>
           <a:lstStyle/>
           <a:p>
-            <a:pPr algn="l" indent="0" marL="0">
+            <a:pPr marL="0" indent="0" algn="l">
               <a:lnSpc>
                 <a:spcPct val="104000"/>
               </a:lnSpc>
@@ -4075,7 +3843,7 @@
           <a:bodyPr wrap="none" lIns="0" tIns="0" rIns="0" bIns="0" rtlCol="0" anchor="ctr"/>
           <a:lstStyle/>
           <a:p>
-            <a:pPr algn="l" indent="0" marL="0">
+            <a:pPr marL="0" indent="0" algn="l">
               <a:lnSpc>
                 <a:spcPct val="100000"/>
               </a:lnSpc>
@@ -4115,6 +3883,13 @@
           </a:solidFill>
           <a:ln/>
         </p:spPr>
+        <p:txBody>
+          <a:bodyPr/>
+          <a:lstStyle/>
+          <a:p>
+            <a:endParaRPr lang="es-VE"/>
+          </a:p>
+        </p:txBody>
       </p:sp>
       <p:sp>
         <p:nvSpPr>
@@ -4137,7 +3912,7 @@
           <a:bodyPr wrap="none" lIns="0" tIns="0" rIns="0" bIns="0" rtlCol="0" anchor="t"/>
           <a:lstStyle/>
           <a:p>
-            <a:pPr algn="l" indent="0" marL="0">
+            <a:pPr marL="0" indent="0" algn="l">
               <a:lnSpc>
                 <a:spcPct val="104000"/>
               </a:lnSpc>
@@ -4163,6 +3938,18 @@
   <p:clrMapOvr>
     <a:masterClrMapping/>
   </p:clrMapOvr>
+  <mc:AlternateContent xmlns:mc="http://schemas.openxmlformats.org/markup-compatibility/2006">
+    <mc:Choice xmlns:p14="http://schemas.microsoft.com/office/powerpoint/2010/main" Requires="p14">
+      <p:transition spd="slow">
+        <p14:reveal/>
+      </p:transition>
+    </mc:Choice>
+    <mc:Fallback>
+      <p:transition spd="slow">
+        <p:fade/>
+      </p:transition>
+    </mc:Fallback>
+  </mc:AlternateContent>
 </p:sld>
 </file>
 
@@ -4204,7 +3991,7 @@
           <a:bodyPr wrap="none" lIns="0" tIns="0" rIns="0" bIns="0" rtlCol="0" anchor="t"/>
           <a:lstStyle/>
           <a:p>
-            <a:pPr algn="l" indent="0" marL="0">
+            <a:pPr marL="0" indent="0" algn="l">
               <a:lnSpc>
                 <a:spcPct val="104000"/>
               </a:lnSpc>
@@ -4246,7 +4033,7 @@
           <a:bodyPr wrap="none" lIns="0" tIns="0" rIns="0" bIns="0" rtlCol="0" anchor="t"/>
           <a:lstStyle/>
           <a:p>
-            <a:pPr algn="l" indent="0" marL="0">
+            <a:pPr marL="0" indent="0" algn="l">
               <a:lnSpc>
                 <a:spcPct val="128000"/>
               </a:lnSpc>
@@ -4288,7 +4075,7 @@
           <a:bodyPr wrap="none" lIns="0" tIns="0" rIns="0" bIns="0" rtlCol="0" anchor="ctr"/>
           <a:lstStyle/>
           <a:p>
-            <a:pPr algn="l" indent="0" marL="0">
+            <a:pPr marL="0" indent="0" algn="l">
               <a:lnSpc>
                 <a:spcPct val="100000"/>
               </a:lnSpc>
@@ -4328,6 +4115,13 @@
           </a:solidFill>
           <a:ln/>
         </p:spPr>
+        <p:txBody>
+          <a:bodyPr/>
+          <a:lstStyle/>
+          <a:p>
+            <a:endParaRPr lang="es-VE"/>
+          </a:p>
+        </p:txBody>
       </p:sp>
       <p:sp>
         <p:nvSpPr>
@@ -4350,7 +4144,7 @@
           <a:bodyPr wrap="none" lIns="0" tIns="0" rIns="0" bIns="0" rtlCol="0" anchor="t"/>
           <a:lstStyle/>
           <a:p>
-            <a:pPr algn="l" indent="0" marL="0">
+            <a:pPr marL="0" indent="0" algn="l">
               <a:lnSpc>
                 <a:spcPct val="104000"/>
               </a:lnSpc>
@@ -4394,7 +4188,7 @@
           </a:bodyPr>
           <a:lstStyle/>
           <a:p>
-            <a:pPr algn="l" indent="0" marL="0">
+            <a:pPr marL="0" indent="0" algn="l">
               <a:lnSpc>
                 <a:spcPct val="128000"/>
               </a:lnSpc>
@@ -4436,7 +4230,7 @@
           <a:bodyPr wrap="none" lIns="0" tIns="0" rIns="0" bIns="0" rtlCol="0" anchor="ctr"/>
           <a:lstStyle/>
           <a:p>
-            <a:pPr algn="l" indent="0" marL="0">
+            <a:pPr marL="0" indent="0" algn="l">
               <a:lnSpc>
                 <a:spcPct val="100000"/>
               </a:lnSpc>
@@ -4476,6 +4270,13 @@
           </a:solidFill>
           <a:ln/>
         </p:spPr>
+        <p:txBody>
+          <a:bodyPr/>
+          <a:lstStyle/>
+          <a:p>
+            <a:endParaRPr lang="es-VE"/>
+          </a:p>
+        </p:txBody>
       </p:sp>
       <p:sp>
         <p:nvSpPr>
@@ -4498,7 +4299,7 @@
           <a:bodyPr wrap="none" lIns="0" tIns="0" rIns="0" bIns="0" rtlCol="0" anchor="t"/>
           <a:lstStyle/>
           <a:p>
-            <a:pPr algn="l" indent="0" marL="0">
+            <a:pPr marL="0" indent="0" algn="l">
               <a:lnSpc>
                 <a:spcPct val="104000"/>
               </a:lnSpc>
@@ -4542,7 +4343,7 @@
           </a:bodyPr>
           <a:lstStyle/>
           <a:p>
-            <a:pPr algn="l" marL="274320" indent="-274320">
+            <a:pPr marL="274320" indent="-274320" algn="l">
               <a:lnSpc>
                 <a:spcPct val="128000"/>
               </a:lnSpc>
@@ -4563,7 +4364,7 @@
             <a:endParaRPr lang="en-US" sz="1350" dirty="0"/>
           </a:p>
           <a:p>
-            <a:pPr algn="l" marL="274320" indent="-274320">
+            <a:pPr marL="274320" indent="-274320" algn="l">
               <a:lnSpc>
                 <a:spcPct val="128000"/>
               </a:lnSpc>
@@ -4584,7 +4385,7 @@
             <a:endParaRPr lang="en-US" sz="1350" dirty="0"/>
           </a:p>
           <a:p>
-            <a:pPr algn="l" marL="274320" indent="-274320">
+            <a:pPr marL="274320" indent="-274320" algn="l">
               <a:lnSpc>
                 <a:spcPct val="128000"/>
               </a:lnSpc>
@@ -4627,7 +4428,7 @@
           <a:bodyPr wrap="none" lIns="0" tIns="0" rIns="0" bIns="0" rtlCol="0" anchor="ctr"/>
           <a:lstStyle/>
           <a:p>
-            <a:pPr algn="l" indent="0" marL="0">
+            <a:pPr marL="0" indent="0" algn="l">
               <a:lnSpc>
                 <a:spcPct val="100000"/>
               </a:lnSpc>
@@ -4667,6 +4468,13 @@
           </a:solidFill>
           <a:ln/>
         </p:spPr>
+        <p:txBody>
+          <a:bodyPr/>
+          <a:lstStyle/>
+          <a:p>
+            <a:endParaRPr lang="es-VE"/>
+          </a:p>
+        </p:txBody>
       </p:sp>
       <p:sp>
         <p:nvSpPr>
@@ -4689,7 +4497,7 @@
           <a:bodyPr wrap="none" lIns="0" tIns="0" rIns="0" bIns="0" rtlCol="0" anchor="t"/>
           <a:lstStyle/>
           <a:p>
-            <a:pPr algn="l" indent="0" marL="0">
+            <a:pPr marL="0" indent="0" algn="l">
               <a:lnSpc>
                 <a:spcPct val="104000"/>
               </a:lnSpc>
@@ -4733,7 +4541,7 @@
           </a:bodyPr>
           <a:lstStyle/>
           <a:p>
-            <a:pPr algn="l" indent="0" marL="0">
+            <a:pPr marL="0" indent="0" algn="l">
               <a:lnSpc>
                 <a:spcPct val="128000"/>
               </a:lnSpc>
@@ -4750,12 +4558,6 @@
               </a:rPr>
               <a:t>230 registros válidos (</a:t>
             </a:r>
-            <a:pPr algn="l" indent="0" marL="0">
-              <a:lnSpc>
-                <a:spcPct val="128000"/>
-              </a:lnSpc>
-              <a:buNone/>
-            </a:pPr>
             <a:r>
               <a:rPr lang="en-US" sz="1350" b="1" dirty="0">
                 <a:solidFill>
@@ -4767,12 +4569,6 @@
               </a:rPr>
               <a:t>95,4%</a:t>
             </a:r>
-            <a:pPr algn="l" indent="0" marL="0">
-              <a:lnSpc>
-                <a:spcPct val="128000"/>
-              </a:lnSpc>
-              <a:buNone/>
-            </a:pPr>
             <a:r>
               <a:rPr lang="en-US" sz="1350" dirty="0">
                 <a:solidFill>
@@ -4809,7 +4605,7 @@
           <a:bodyPr wrap="none" lIns="0" tIns="0" rIns="0" bIns="0" rtlCol="0" anchor="ctr"/>
           <a:lstStyle/>
           <a:p>
-            <a:pPr algn="l" indent="0" marL="0">
+            <a:pPr marL="0" indent="0" algn="l">
               <a:lnSpc>
                 <a:spcPct val="100000"/>
               </a:lnSpc>
@@ -4849,6 +4645,13 @@
           </a:solidFill>
           <a:ln/>
         </p:spPr>
+        <p:txBody>
+          <a:bodyPr/>
+          <a:lstStyle/>
+          <a:p>
+            <a:endParaRPr lang="es-VE"/>
+          </a:p>
+        </p:txBody>
       </p:sp>
       <p:sp>
         <p:nvSpPr>
@@ -4871,7 +4674,7 @@
           <a:bodyPr wrap="none" lIns="0" tIns="0" rIns="0" bIns="0" rtlCol="0" anchor="t"/>
           <a:lstStyle/>
           <a:p>
-            <a:pPr algn="l" indent="0" marL="0">
+            <a:pPr marL="0" indent="0" algn="l">
               <a:lnSpc>
                 <a:spcPct val="104000"/>
               </a:lnSpc>
@@ -4915,7 +4718,7 @@
           </a:bodyPr>
           <a:lstStyle/>
           <a:p>
-            <a:pPr algn="l" indent="0" marL="0">
+            <a:pPr marL="0" indent="0" algn="l">
               <a:lnSpc>
                 <a:spcPct val="128000"/>
               </a:lnSpc>
@@ -4957,7 +4760,7 @@
           <a:bodyPr wrap="none" lIns="0" tIns="0" rIns="0" bIns="0" rtlCol="0" anchor="ctr"/>
           <a:lstStyle/>
           <a:p>
-            <a:pPr algn="l" indent="0" marL="0">
+            <a:pPr marL="0" indent="0" algn="l">
               <a:lnSpc>
                 <a:spcPct val="100000"/>
               </a:lnSpc>
@@ -4997,6 +4800,13 @@
           </a:solidFill>
           <a:ln/>
         </p:spPr>
+        <p:txBody>
+          <a:bodyPr/>
+          <a:lstStyle/>
+          <a:p>
+            <a:endParaRPr lang="es-VE"/>
+          </a:p>
+        </p:txBody>
       </p:sp>
       <p:sp>
         <p:nvSpPr>
@@ -5019,7 +4829,7 @@
           <a:bodyPr wrap="none" lIns="0" tIns="0" rIns="0" bIns="0" rtlCol="0" anchor="t"/>
           <a:lstStyle/>
           <a:p>
-            <a:pPr algn="l" indent="0" marL="0">
+            <a:pPr marL="0" indent="0" algn="l">
               <a:lnSpc>
                 <a:spcPct val="104000"/>
               </a:lnSpc>
@@ -5063,7 +4873,7 @@
           </a:bodyPr>
           <a:lstStyle/>
           <a:p>
-            <a:pPr algn="l" indent="0" marL="0">
+            <a:pPr marL="0" indent="0" algn="l">
               <a:lnSpc>
                 <a:spcPct val="128000"/>
               </a:lnSpc>
@@ -5089,6 +4899,18 @@
   <p:clrMapOvr>
     <a:masterClrMapping/>
   </p:clrMapOvr>
+  <mc:AlternateContent xmlns:mc="http://schemas.openxmlformats.org/markup-compatibility/2006">
+    <mc:Choice xmlns:p14="http://schemas.microsoft.com/office/powerpoint/2010/main" Requires="p14">
+      <p:transition spd="slow">
+        <p14:prism/>
+      </p:transition>
+    </mc:Choice>
+    <mc:Fallback>
+      <p:transition spd="slow">
+        <p:fade/>
+      </p:transition>
+    </mc:Fallback>
+  </mc:AlternateContent>
 </p:sld>
 </file>
 
@@ -5130,7 +4952,7 @@
           <a:bodyPr wrap="none" lIns="0" tIns="0" rIns="0" bIns="0" rtlCol="0" anchor="t"/>
           <a:lstStyle/>
           <a:p>
-            <a:pPr algn="l" indent="0" marL="0">
+            <a:pPr marL="0" indent="0" algn="l">
               <a:lnSpc>
                 <a:spcPct val="104000"/>
               </a:lnSpc>
@@ -5153,227 +4975,7 @@
       </p:sp>
       <p:pic>
         <p:nvPicPr>
-          <p:cNvPr id="3" name="Image 0" descr="preencoded.png">    </p:cNvPr>
-          <p:cNvPicPr>
-            <a:picLocks noChangeAspect="1"/>
-          </p:cNvPicPr>
-          <p:nvPr/>
-        </p:nvPicPr>
-        <p:blipFill>
-          <a:blip r:embed="rId1"/>
-          <a:stretch>
-            <a:fillRect/>
-          </a:stretch>
-        </p:blipFill>
-        <p:spPr>
-          <a:xfrm>
-            <a:off x="661475" y="3104158"/>
-            <a:ext cx="762378" cy="762397"/>
-          </a:xfrm>
-          <a:prstGeom prst="rect">
-            <a:avLst/>
-          </a:prstGeom>
-        </p:spPr>
-      </p:pic>
-      <p:sp>
-        <p:nvSpPr>
-          <p:cNvPr id="4" name="Text 1"/>
-          <p:cNvSpPr/>
-          <p:nvPr/>
-        </p:nvSpPr>
-        <p:spPr>
-          <a:xfrm>
-            <a:off x="1660087" y="3104158"/>
-            <a:ext cx="2466814" cy="295275"/>
-          </a:xfrm>
-          <a:prstGeom prst="rect">
-            <a:avLst/>
-          </a:prstGeom>
-          <a:noFill/>
-          <a:ln/>
-        </p:spPr>
-        <p:txBody>
-          <a:bodyPr wrap="none" lIns="0" tIns="0" rIns="0" bIns="0" rtlCol="0" anchor="t"/>
-          <a:lstStyle/>
-          <a:p>
-            <a:pPr algn="l" indent="0" marL="0">
-              <a:lnSpc>
-                <a:spcPct val="104000"/>
-              </a:lnSpc>
-              <a:buNone/>
-            </a:pPr>
-            <a:r>
-              <a:rPr lang="en-US" sz="1850" dirty="0">
-                <a:solidFill>
-                  <a:srgbClr val="161613"/>
-                </a:solidFill>
-                <a:latin typeface="DM Sans Medium" pitchFamily="34" charset="0"/>
-                <a:ea typeface="DM Sans Medium" pitchFamily="34" charset="-122"/>
-                <a:cs typeface="DM Sans Medium" pitchFamily="34" charset="-120"/>
-              </a:rPr>
-              <a:t>SQL</a:t>
-            </a:r>
-            <a:endParaRPr lang="en-US" sz="1850" dirty="0"/>
-          </a:p>
-        </p:txBody>
-      </p:sp>
-      <p:sp>
-        <p:nvSpPr>
-          <p:cNvPr id="5" name="Text 2"/>
-          <p:cNvSpPr/>
-          <p:nvPr/>
-        </p:nvSpPr>
-        <p:spPr>
-          <a:xfrm>
-            <a:off x="1660087" y="3512840"/>
-            <a:ext cx="2466814" cy="1209675"/>
-          </a:xfrm>
-          <a:prstGeom prst="rect">
-            <a:avLst/>
-          </a:prstGeom>
-          <a:noFill/>
-          <a:ln/>
-        </p:spPr>
-        <p:txBody>
-          <a:bodyPr wrap="square" lIns="0" tIns="0" rIns="0" bIns="0" rtlCol="0" anchor="t">
-            <a:normAutofit/>
-          </a:bodyPr>
-          <a:lstStyle/>
-          <a:p>
-            <a:pPr algn="l" indent="0" marL="0">
-              <a:lnSpc>
-                <a:spcPct val="133000"/>
-              </a:lnSpc>
-              <a:buNone/>
-            </a:pPr>
-            <a:r>
-              <a:rPr lang="en-US" sz="1450" dirty="0">
-                <a:solidFill>
-                  <a:srgbClr val="161613"/>
-                </a:solidFill>
-                <a:latin typeface="Inter" pitchFamily="34" charset="0"/>
-                <a:ea typeface="Inter" pitchFamily="34" charset="-122"/>
-                <a:cs typeface="Inter" pitchFamily="34" charset="-120"/>
-              </a:rPr>
-              <a:t>Modelado relacional y diseño del esquema en estrella. Base estructural del sistema de datos.</a:t>
-            </a:r>
-            <a:endParaRPr lang="en-US" sz="1450" dirty="0"/>
-          </a:p>
-        </p:txBody>
-      </p:sp>
-      <p:pic>
-        <p:nvPicPr>
-          <p:cNvPr id="6" name="Image 1" descr="preencoded.png">    </p:cNvPr>
-          <p:cNvPicPr>
-            <a:picLocks noChangeAspect="1"/>
-          </p:cNvPicPr>
-          <p:nvPr/>
-        </p:nvPicPr>
-        <p:blipFill>
-          <a:blip r:embed="rId2"/>
-          <a:stretch>
-            <a:fillRect/>
-          </a:stretch>
-        </p:blipFill>
-        <p:spPr>
-          <a:xfrm>
-            <a:off x="4363135" y="3104158"/>
-            <a:ext cx="762378" cy="762397"/>
-          </a:xfrm>
-          <a:prstGeom prst="rect">
-            <a:avLst/>
-          </a:prstGeom>
-        </p:spPr>
-      </p:pic>
-      <p:sp>
-        <p:nvSpPr>
-          <p:cNvPr id="7" name="Text 3"/>
-          <p:cNvSpPr/>
-          <p:nvPr/>
-        </p:nvSpPr>
-        <p:spPr>
-          <a:xfrm>
-            <a:off x="5361746" y="3104158"/>
-            <a:ext cx="2466814" cy="295275"/>
-          </a:xfrm>
-          <a:prstGeom prst="rect">
-            <a:avLst/>
-          </a:prstGeom>
-          <a:noFill/>
-          <a:ln/>
-        </p:spPr>
-        <p:txBody>
-          <a:bodyPr wrap="none" lIns="0" tIns="0" rIns="0" bIns="0" rtlCol="0" anchor="t"/>
-          <a:lstStyle/>
-          <a:p>
-            <a:pPr algn="l" indent="0" marL="0">
-              <a:lnSpc>
-                <a:spcPct val="104000"/>
-              </a:lnSpc>
-              <a:buNone/>
-            </a:pPr>
-            <a:r>
-              <a:rPr lang="en-US" sz="1850" dirty="0">
-                <a:solidFill>
-                  <a:srgbClr val="161613"/>
-                </a:solidFill>
-                <a:latin typeface="DM Sans Medium" pitchFamily="34" charset="0"/>
-                <a:ea typeface="DM Sans Medium" pitchFamily="34" charset="-122"/>
-                <a:cs typeface="DM Sans Medium" pitchFamily="34" charset="-120"/>
-              </a:rPr>
-              <a:t>Python</a:t>
-            </a:r>
-            <a:endParaRPr lang="en-US" sz="1850" dirty="0"/>
-          </a:p>
-        </p:txBody>
-      </p:sp>
-      <p:sp>
-        <p:nvSpPr>
-          <p:cNvPr id="8" name="Text 4"/>
-          <p:cNvSpPr/>
-          <p:nvPr/>
-        </p:nvSpPr>
-        <p:spPr>
-          <a:xfrm>
-            <a:off x="5361746" y="3512840"/>
-            <a:ext cx="2466814" cy="1209675"/>
-          </a:xfrm>
-          <a:prstGeom prst="rect">
-            <a:avLst/>
-          </a:prstGeom>
-          <a:noFill/>
-          <a:ln/>
-        </p:spPr>
-        <p:txBody>
-          <a:bodyPr wrap="square" lIns="0" tIns="0" rIns="0" bIns="0" rtlCol="0" anchor="t">
-            <a:normAutofit/>
-          </a:bodyPr>
-          <a:lstStyle/>
-          <a:p>
-            <a:pPr algn="l" indent="0" marL="0">
-              <a:lnSpc>
-                <a:spcPct val="133000"/>
-              </a:lnSpc>
-              <a:buNone/>
-            </a:pPr>
-            <a:r>
-              <a:rPr lang="en-US" sz="1450" dirty="0">
-                <a:solidFill>
-                  <a:srgbClr val="161613"/>
-                </a:solidFill>
-                <a:latin typeface="Inter" pitchFamily="34" charset="0"/>
-                <a:ea typeface="Inter" pitchFamily="34" charset="-122"/>
-                <a:cs typeface="Inter" pitchFamily="34" charset="-120"/>
-              </a:rPr>
-              <a:t>Limpieza ETL, cálculo de KPIs y generación del modelo de forecast estadístico.</a:t>
-            </a:r>
-            <a:endParaRPr lang="en-US" sz="1450" dirty="0"/>
-          </a:p>
-        </p:txBody>
-      </p:sp>
-      <p:pic>
-        <p:nvPicPr>
-          <p:cNvPr id="9" name="Image 2" descr="preencoded.png">    </p:cNvPr>
+          <p:cNvPr id="3" name="Image 0" descr="preencoded.png"/>
           <p:cNvPicPr>
             <a:picLocks noChangeAspect="1"/>
           </p:cNvPicPr>
@@ -5387,7 +4989,7 @@
         </p:blipFill>
         <p:spPr>
           <a:xfrm>
-            <a:off x="8064794" y="3104158"/>
+            <a:off x="661475" y="3104158"/>
             <a:ext cx="762378" cy="762397"/>
           </a:xfrm>
           <a:prstGeom prst="rect">
@@ -5397,13 +4999,13 @@
       </p:pic>
       <p:sp>
         <p:nvSpPr>
-          <p:cNvPr id="10" name="Text 5"/>
-          <p:cNvSpPr/>
-          <p:nvPr/>
-        </p:nvSpPr>
-        <p:spPr>
-          <a:xfrm>
-            <a:off x="9063406" y="3104158"/>
+          <p:cNvPr id="4" name="Text 1"/>
+          <p:cNvSpPr/>
+          <p:nvPr/>
+        </p:nvSpPr>
+        <p:spPr>
+          <a:xfrm>
+            <a:off x="1660087" y="3104158"/>
             <a:ext cx="2466814" cy="295275"/>
           </a:xfrm>
           <a:prstGeom prst="rect">
@@ -5416,7 +5018,7 @@
           <a:bodyPr wrap="none" lIns="0" tIns="0" rIns="0" bIns="0" rtlCol="0" anchor="t"/>
           <a:lstStyle/>
           <a:p>
-            <a:pPr algn="l" indent="0" marL="0">
+            <a:pPr marL="0" indent="0" algn="l">
               <a:lnSpc>
                 <a:spcPct val="104000"/>
               </a:lnSpc>
@@ -5431,7 +5033,7 @@
                 <a:ea typeface="DM Sans Medium" pitchFamily="34" charset="-122"/>
                 <a:cs typeface="DM Sans Medium" pitchFamily="34" charset="-120"/>
               </a:rPr>
-              <a:t>Power BI</a:t>
+              <a:t>SQL</a:t>
             </a:r>
             <a:endParaRPr lang="en-US" sz="1850" dirty="0"/>
           </a:p>
@@ -5439,13 +5041,13 @@
       </p:sp>
       <p:sp>
         <p:nvSpPr>
-          <p:cNvPr id="11" name="Text 6"/>
-          <p:cNvSpPr/>
-          <p:nvPr/>
-        </p:nvSpPr>
-        <p:spPr>
-          <a:xfrm>
-            <a:off x="9063406" y="3512840"/>
+          <p:cNvPr id="5" name="Text 2"/>
+          <p:cNvSpPr/>
+          <p:nvPr/>
+        </p:nvSpPr>
+        <p:spPr>
+          <a:xfrm>
+            <a:off x="1660087" y="3512840"/>
             <a:ext cx="2466814" cy="1209675"/>
           </a:xfrm>
           <a:prstGeom prst="rect">
@@ -5460,7 +5062,227 @@
           </a:bodyPr>
           <a:lstStyle/>
           <a:p>
-            <a:pPr algn="l" indent="0" marL="0">
+            <a:pPr marL="0" indent="0" algn="l">
+              <a:lnSpc>
+                <a:spcPct val="133000"/>
+              </a:lnSpc>
+              <a:buNone/>
+            </a:pPr>
+            <a:r>
+              <a:rPr lang="en-US" sz="1450" dirty="0">
+                <a:solidFill>
+                  <a:srgbClr val="161613"/>
+                </a:solidFill>
+                <a:latin typeface="Inter" pitchFamily="34" charset="0"/>
+                <a:ea typeface="Inter" pitchFamily="34" charset="-122"/>
+                <a:cs typeface="Inter" pitchFamily="34" charset="-120"/>
+              </a:rPr>
+              <a:t>Modelado relacional y diseño del esquema en estrella. Base estructural del sistema de datos.</a:t>
+            </a:r>
+            <a:endParaRPr lang="en-US" sz="1450" dirty="0"/>
+          </a:p>
+        </p:txBody>
+      </p:sp>
+      <p:pic>
+        <p:nvPicPr>
+          <p:cNvPr id="6" name="Image 1" descr="preencoded.png"/>
+          <p:cNvPicPr>
+            <a:picLocks noChangeAspect="1"/>
+          </p:cNvPicPr>
+          <p:nvPr/>
+        </p:nvPicPr>
+        <p:blipFill>
+          <a:blip r:embed="rId4"/>
+          <a:stretch>
+            <a:fillRect/>
+          </a:stretch>
+        </p:blipFill>
+        <p:spPr>
+          <a:xfrm>
+            <a:off x="4363135" y="3104158"/>
+            <a:ext cx="762378" cy="762397"/>
+          </a:xfrm>
+          <a:prstGeom prst="rect">
+            <a:avLst/>
+          </a:prstGeom>
+        </p:spPr>
+      </p:pic>
+      <p:sp>
+        <p:nvSpPr>
+          <p:cNvPr id="7" name="Text 3"/>
+          <p:cNvSpPr/>
+          <p:nvPr/>
+        </p:nvSpPr>
+        <p:spPr>
+          <a:xfrm>
+            <a:off x="5361746" y="3104158"/>
+            <a:ext cx="2466814" cy="295275"/>
+          </a:xfrm>
+          <a:prstGeom prst="rect">
+            <a:avLst/>
+          </a:prstGeom>
+          <a:noFill/>
+          <a:ln/>
+        </p:spPr>
+        <p:txBody>
+          <a:bodyPr wrap="none" lIns="0" tIns="0" rIns="0" bIns="0" rtlCol="0" anchor="t"/>
+          <a:lstStyle/>
+          <a:p>
+            <a:pPr marL="0" indent="0" algn="l">
+              <a:lnSpc>
+                <a:spcPct val="104000"/>
+              </a:lnSpc>
+              <a:buNone/>
+            </a:pPr>
+            <a:r>
+              <a:rPr lang="en-US" sz="1850" dirty="0">
+                <a:solidFill>
+                  <a:srgbClr val="161613"/>
+                </a:solidFill>
+                <a:latin typeface="DM Sans Medium" pitchFamily="34" charset="0"/>
+                <a:ea typeface="DM Sans Medium" pitchFamily="34" charset="-122"/>
+                <a:cs typeface="DM Sans Medium" pitchFamily="34" charset="-120"/>
+              </a:rPr>
+              <a:t>Python</a:t>
+            </a:r>
+            <a:endParaRPr lang="en-US" sz="1850" dirty="0"/>
+          </a:p>
+        </p:txBody>
+      </p:sp>
+      <p:sp>
+        <p:nvSpPr>
+          <p:cNvPr id="8" name="Text 4"/>
+          <p:cNvSpPr/>
+          <p:nvPr/>
+        </p:nvSpPr>
+        <p:spPr>
+          <a:xfrm>
+            <a:off x="5361746" y="3512840"/>
+            <a:ext cx="2466814" cy="1209675"/>
+          </a:xfrm>
+          <a:prstGeom prst="rect">
+            <a:avLst/>
+          </a:prstGeom>
+          <a:noFill/>
+          <a:ln/>
+        </p:spPr>
+        <p:txBody>
+          <a:bodyPr wrap="square" lIns="0" tIns="0" rIns="0" bIns="0" rtlCol="0" anchor="t">
+            <a:normAutofit/>
+          </a:bodyPr>
+          <a:lstStyle/>
+          <a:p>
+            <a:pPr marL="0" indent="0" algn="l">
+              <a:lnSpc>
+                <a:spcPct val="133000"/>
+              </a:lnSpc>
+              <a:buNone/>
+            </a:pPr>
+            <a:r>
+              <a:rPr lang="en-US" sz="1450" dirty="0">
+                <a:solidFill>
+                  <a:srgbClr val="161613"/>
+                </a:solidFill>
+                <a:latin typeface="Inter" pitchFamily="34" charset="0"/>
+                <a:ea typeface="Inter" pitchFamily="34" charset="-122"/>
+                <a:cs typeface="Inter" pitchFamily="34" charset="-120"/>
+              </a:rPr>
+              <a:t>Limpieza ETL, cálculo de KPIs y generación del modelo de forecast estadístico.</a:t>
+            </a:r>
+            <a:endParaRPr lang="en-US" sz="1450" dirty="0"/>
+          </a:p>
+        </p:txBody>
+      </p:sp>
+      <p:pic>
+        <p:nvPicPr>
+          <p:cNvPr id="9" name="Image 2" descr="preencoded.png"/>
+          <p:cNvPicPr>
+            <a:picLocks noChangeAspect="1"/>
+          </p:cNvPicPr>
+          <p:nvPr/>
+        </p:nvPicPr>
+        <p:blipFill>
+          <a:blip r:embed="rId5"/>
+          <a:stretch>
+            <a:fillRect/>
+          </a:stretch>
+        </p:blipFill>
+        <p:spPr>
+          <a:xfrm>
+            <a:off x="8064794" y="3104158"/>
+            <a:ext cx="762378" cy="762397"/>
+          </a:xfrm>
+          <a:prstGeom prst="rect">
+            <a:avLst/>
+          </a:prstGeom>
+        </p:spPr>
+      </p:pic>
+      <p:sp>
+        <p:nvSpPr>
+          <p:cNvPr id="10" name="Text 5"/>
+          <p:cNvSpPr/>
+          <p:nvPr/>
+        </p:nvSpPr>
+        <p:spPr>
+          <a:xfrm>
+            <a:off x="9063406" y="3104158"/>
+            <a:ext cx="2466814" cy="295275"/>
+          </a:xfrm>
+          <a:prstGeom prst="rect">
+            <a:avLst/>
+          </a:prstGeom>
+          <a:noFill/>
+          <a:ln/>
+        </p:spPr>
+        <p:txBody>
+          <a:bodyPr wrap="none" lIns="0" tIns="0" rIns="0" bIns="0" rtlCol="0" anchor="t"/>
+          <a:lstStyle/>
+          <a:p>
+            <a:pPr marL="0" indent="0" algn="l">
+              <a:lnSpc>
+                <a:spcPct val="104000"/>
+              </a:lnSpc>
+              <a:buNone/>
+            </a:pPr>
+            <a:r>
+              <a:rPr lang="en-US" sz="1850" dirty="0">
+                <a:solidFill>
+                  <a:srgbClr val="161613"/>
+                </a:solidFill>
+                <a:latin typeface="DM Sans Medium" pitchFamily="34" charset="0"/>
+                <a:ea typeface="DM Sans Medium" pitchFamily="34" charset="-122"/>
+                <a:cs typeface="DM Sans Medium" pitchFamily="34" charset="-120"/>
+              </a:rPr>
+              <a:t>Power BI</a:t>
+            </a:r>
+            <a:endParaRPr lang="en-US" sz="1850" dirty="0"/>
+          </a:p>
+        </p:txBody>
+      </p:sp>
+      <p:sp>
+        <p:nvSpPr>
+          <p:cNvPr id="11" name="Text 6"/>
+          <p:cNvSpPr/>
+          <p:nvPr/>
+        </p:nvSpPr>
+        <p:spPr>
+          <a:xfrm>
+            <a:off x="9063406" y="3512840"/>
+            <a:ext cx="2466814" cy="1209675"/>
+          </a:xfrm>
+          <a:prstGeom prst="rect">
+            <a:avLst/>
+          </a:prstGeom>
+          <a:noFill/>
+          <a:ln/>
+        </p:spPr>
+        <p:txBody>
+          <a:bodyPr wrap="square" lIns="0" tIns="0" rIns="0" bIns="0" rtlCol="0" anchor="t">
+            <a:normAutofit/>
+          </a:bodyPr>
+          <a:lstStyle/>
+          <a:p>
+            <a:pPr marL="0" indent="0" algn="l">
               <a:lnSpc>
                 <a:spcPct val="133000"/>
               </a:lnSpc>
@@ -5486,6 +5308,18 @@
   <p:clrMapOvr>
     <a:masterClrMapping/>
   </p:clrMapOvr>
+  <mc:AlternateContent xmlns:mc="http://schemas.openxmlformats.org/markup-compatibility/2006">
+    <mc:Choice xmlns:p14="http://schemas.microsoft.com/office/powerpoint/2010/main" Requires="p14">
+      <p:transition spd="slow">
+        <p14:prism/>
+      </p:transition>
+    </mc:Choice>
+    <mc:Fallback>
+      <p:transition spd="slow">
+        <p:fade/>
+      </p:transition>
+    </mc:Fallback>
+  </mc:AlternateContent>
 </p:sld>
 </file>
 
@@ -5527,7 +5361,7 @@
           <a:bodyPr wrap="none" lIns="0" tIns="0" rIns="0" bIns="0" rtlCol="0" anchor="t"/>
           <a:lstStyle/>
           <a:p>
-            <a:pPr algn="l" indent="0" marL="0">
+            <a:pPr marL="0" indent="0" algn="l">
               <a:lnSpc>
                 <a:spcPct val="104000"/>
               </a:lnSpc>
@@ -5557,7 +5391,7 @@
         <p:spPr>
           <a:xfrm>
             <a:off x="661475" y="2153245"/>
-            <a:ext cx="5316206" cy="623788"/>
+            <a:ext cx="5187234" cy="590649"/>
           </a:xfrm>
           <a:prstGeom prst="rect">
             <a:avLst/>
@@ -5569,7 +5403,7 @@
           <a:bodyPr wrap="none" lIns="0" tIns="0" rIns="0" bIns="0" rtlCol="0" anchor="t"/>
           <a:lstStyle/>
           <a:p>
-            <a:pPr algn="ctr" indent="0" marL="0">
+            <a:pPr marL="0" indent="0" algn="ctr">
               <a:lnSpc>
                 <a:spcPct val="83000"/>
               </a:lnSpc>
@@ -5611,7 +5445,7 @@
           <a:bodyPr wrap="none" lIns="0" tIns="0" rIns="0" bIns="0" rtlCol="0" anchor="t"/>
           <a:lstStyle/>
           <a:p>
-            <a:pPr algn="ctr" indent="0" marL="0">
+            <a:pPr marL="0" indent="0" algn="ctr">
               <a:lnSpc>
                 <a:spcPct val="104000"/>
               </a:lnSpc>
@@ -5653,7 +5487,7 @@
           <a:bodyPr wrap="none" lIns="0" tIns="0" rIns="0" bIns="0" rtlCol="0" anchor="t"/>
           <a:lstStyle/>
           <a:p>
-            <a:pPr algn="ctr" indent="0" marL="0">
+            <a:pPr marL="0" indent="0" algn="ctr">
               <a:lnSpc>
                 <a:spcPct val="133000"/>
               </a:lnSpc>
@@ -5695,7 +5529,7 @@
           <a:bodyPr wrap="none" lIns="0" tIns="0" rIns="0" bIns="0" rtlCol="0" anchor="t"/>
           <a:lstStyle/>
           <a:p>
-            <a:pPr algn="ctr" indent="0" marL="0">
+            <a:pPr marL="0" indent="0" algn="ctr">
               <a:lnSpc>
                 <a:spcPct val="83000"/>
               </a:lnSpc>
@@ -5737,7 +5571,7 @@
           <a:bodyPr wrap="none" lIns="0" tIns="0" rIns="0" bIns="0" rtlCol="0" anchor="t"/>
           <a:lstStyle/>
           <a:p>
-            <a:pPr algn="ctr" indent="0" marL="0">
+            <a:pPr marL="0" indent="0" algn="ctr">
               <a:lnSpc>
                 <a:spcPct val="104000"/>
               </a:lnSpc>
@@ -5779,7 +5613,7 @@
           <a:bodyPr wrap="none" lIns="0" tIns="0" rIns="0" bIns="0" rtlCol="0" anchor="t"/>
           <a:lstStyle/>
           <a:p>
-            <a:pPr algn="ctr" indent="0" marL="0">
+            <a:pPr marL="0" indent="0" algn="ctr">
               <a:lnSpc>
                 <a:spcPct val="133000"/>
               </a:lnSpc>
@@ -5821,7 +5655,7 @@
           <a:bodyPr wrap="none" lIns="0" tIns="0" rIns="0" bIns="0" rtlCol="0" anchor="t"/>
           <a:lstStyle/>
           <a:p>
-            <a:pPr algn="ctr" indent="0" marL="0">
+            <a:pPr marL="0" indent="0" algn="ctr">
               <a:lnSpc>
                 <a:spcPct val="83000"/>
               </a:lnSpc>
@@ -5863,7 +5697,7 @@
           <a:bodyPr wrap="none" lIns="0" tIns="0" rIns="0" bIns="0" rtlCol="0" anchor="t"/>
           <a:lstStyle/>
           <a:p>
-            <a:pPr algn="ctr" indent="0" marL="0">
+            <a:pPr marL="0" indent="0" algn="ctr">
               <a:lnSpc>
                 <a:spcPct val="104000"/>
               </a:lnSpc>
@@ -5905,7 +5739,7 @@
           <a:bodyPr wrap="none" lIns="0" tIns="0" rIns="0" bIns="0" rtlCol="0" anchor="t"/>
           <a:lstStyle/>
           <a:p>
-            <a:pPr algn="ctr" indent="0" marL="0">
+            <a:pPr marL="0" indent="0" algn="ctr">
               <a:lnSpc>
                 <a:spcPct val="133000"/>
               </a:lnSpc>
@@ -5947,7 +5781,7 @@
           <a:bodyPr wrap="none" lIns="0" tIns="0" rIns="0" bIns="0" rtlCol="0" anchor="t"/>
           <a:lstStyle/>
           <a:p>
-            <a:pPr algn="ctr" indent="0" marL="0">
+            <a:pPr marL="0" indent="0" algn="ctr">
               <a:lnSpc>
                 <a:spcPct val="83000"/>
               </a:lnSpc>
@@ -5989,7 +5823,7 @@
           <a:bodyPr wrap="none" lIns="0" tIns="0" rIns="0" bIns="0" rtlCol="0" anchor="t"/>
           <a:lstStyle/>
           <a:p>
-            <a:pPr algn="ctr" indent="0" marL="0">
+            <a:pPr marL="0" indent="0" algn="ctr">
               <a:lnSpc>
                 <a:spcPct val="104000"/>
               </a:lnSpc>
@@ -6031,7 +5865,7 @@
           <a:bodyPr wrap="none" lIns="0" tIns="0" rIns="0" bIns="0" rtlCol="0" anchor="t"/>
           <a:lstStyle/>
           <a:p>
-            <a:pPr algn="ctr" indent="0" marL="0">
+            <a:pPr marL="0" indent="0" algn="ctr">
               <a:lnSpc>
                 <a:spcPct val="133000"/>
               </a:lnSpc>
@@ -6052,11 +5886,53 @@
           </a:p>
         </p:txBody>
       </p:sp>
+      <p:pic>
+        <p:nvPicPr>
+          <p:cNvPr id="16" name="Imagen 15" descr="Código QR&#10;&#10;El contenido generado por IA puede ser incorrecto.">
+            <a:extLst>
+              <a:ext uri="{FF2B5EF4-FFF2-40B4-BE49-F238E27FC236}">
+                <a16:creationId xmlns:a16="http://schemas.microsoft.com/office/drawing/2014/main" id="{50C07859-6803-9864-7E25-0429BD3B1EEF}"/>
+              </a:ext>
+            </a:extLst>
+          </p:cNvPr>
+          <p:cNvPicPr>
+            <a:picLocks noChangeAspect="1"/>
+          </p:cNvPicPr>
+          <p:nvPr/>
+        </p:nvPicPr>
+        <p:blipFill>
+          <a:blip r:embed="rId3"/>
+          <a:stretch>
+            <a:fillRect/>
+          </a:stretch>
+        </p:blipFill>
+        <p:spPr>
+          <a:xfrm>
+            <a:off x="10222302" y="1924"/>
+            <a:ext cx="1969698" cy="1969698"/>
+          </a:xfrm>
+          <a:prstGeom prst="rect">
+            <a:avLst/>
+          </a:prstGeom>
+        </p:spPr>
+      </p:pic>
     </p:spTree>
   </p:cSld>
   <p:clrMapOvr>
     <a:masterClrMapping/>
   </p:clrMapOvr>
+  <mc:AlternateContent xmlns:mc="http://schemas.openxmlformats.org/markup-compatibility/2006">
+    <mc:Choice xmlns:p14="http://schemas.microsoft.com/office/powerpoint/2010/main" Requires="p14">
+      <p:transition spd="slow">
+        <p14:prism/>
+      </p:transition>
+    </mc:Choice>
+    <mc:Fallback>
+      <p:transition spd="slow">
+        <p:fade/>
+      </p:transition>
+    </mc:Fallback>
+  </mc:AlternateContent>
 </p:sld>
 </file>
 
@@ -6079,14 +5955,14 @@
       </p:grpSpPr>
       <p:pic>
         <p:nvPicPr>
-          <p:cNvPr id="2" name="Image 0" descr="preencoded.png">    </p:cNvPr>
+          <p:cNvPr id="2" name="Image 0" descr="preencoded.png"/>
           <p:cNvPicPr>
             <a:picLocks noChangeAspect="1"/>
           </p:cNvPicPr>
           <p:nvPr/>
         </p:nvPicPr>
         <p:blipFill>
-          <a:blip r:embed="rId1"/>
+          <a:blip r:embed="rId3"/>
           <a:stretch>
             <a:fillRect/>
           </a:stretch>
@@ -6122,7 +5998,7 @@
           <a:bodyPr wrap="none" lIns="0" tIns="0" rIns="0" bIns="0" rtlCol="0" anchor="t"/>
           <a:lstStyle/>
           <a:p>
-            <a:pPr algn="l" indent="0" marL="0">
+            <a:pPr marL="0" indent="0" algn="l">
               <a:lnSpc>
                 <a:spcPct val="104000"/>
               </a:lnSpc>
@@ -6145,140 +6021,7 @@
       </p:sp>
       <p:pic>
         <p:nvPicPr>
-          <p:cNvPr id="4" name="Image 1" descr="preencoded.png">    </p:cNvPr>
-          <p:cNvPicPr>
-            <a:picLocks noChangeAspect="1"/>
-          </p:cNvPicPr>
-          <p:nvPr/>
-        </p:nvPicPr>
-        <p:blipFill>
-          <a:blip r:embed="rId2">
-            <a:extLst>
-              <a:ext uri="{96DAC541-7B7A-43D3-8B79-37D633B846F1}">
-                <asvg:svgBlip xmlns:asvg="http://schemas.microsoft.com/office/drawing/2016/SVG/main" r:embed="rId3"/>
-              </a:ext>
-            </a:extLst>
-          </a:blip>
-          <a:stretch>
-            <a:fillRect/>
-          </a:stretch>
-        </p:blipFill>
-        <p:spPr>
-          <a:xfrm>
-            <a:off x="661475" y="1513483"/>
-            <a:ext cx="6296860" cy="1442343"/>
-          </a:xfrm>
-          <a:prstGeom prst="rect">
-            <a:avLst/>
-          </a:prstGeom>
-        </p:spPr>
-      </p:pic>
-      <p:sp>
-        <p:nvSpPr>
-          <p:cNvPr id="5" name="Text 1"/>
-          <p:cNvSpPr/>
-          <p:nvPr/>
-        </p:nvSpPr>
-        <p:spPr>
-          <a:xfrm>
-            <a:off x="977479" y="1727895"/>
-            <a:ext cx="5766449" cy="295275"/>
-          </a:xfrm>
-          <a:prstGeom prst="rect">
-            <a:avLst/>
-          </a:prstGeom>
-          <a:noFill/>
-          <a:ln/>
-        </p:spPr>
-        <p:txBody>
-          <a:bodyPr wrap="none" lIns="0" tIns="0" rIns="0" bIns="0" rtlCol="0" anchor="t"/>
-          <a:lstStyle/>
-          <a:p>
-            <a:pPr algn="l" indent="0" marL="0">
-              <a:lnSpc>
-                <a:spcPct val="104000"/>
-              </a:lnSpc>
-              <a:buNone/>
-            </a:pPr>
-            <a:r>
-              <a:rPr lang="en-US" sz="1850" dirty="0">
-                <a:solidFill>
-                  <a:srgbClr val="161613"/>
-                </a:solidFill>
-                <a:latin typeface="DM Sans Medium" pitchFamily="34" charset="0"/>
-                <a:ea typeface="DM Sans Medium" pitchFamily="34" charset="-122"/>
-                <a:cs typeface="DM Sans Medium" pitchFamily="34" charset="-120"/>
-              </a:rPr>
-              <a:t>Servicios B2B Corporativos</a:t>
-            </a:r>
-            <a:endParaRPr lang="en-US" sz="1850" dirty="0"/>
-          </a:p>
-        </p:txBody>
-      </p:sp>
-      <p:sp>
-        <p:nvSpPr>
-          <p:cNvPr id="6" name="Text 2"/>
-          <p:cNvSpPr/>
-          <p:nvPr/>
-        </p:nvSpPr>
-        <p:spPr>
-          <a:xfrm>
-            <a:off x="977479" y="2136577"/>
-            <a:ext cx="5766449" cy="604838"/>
-          </a:xfrm>
-          <a:prstGeom prst="rect">
-            <a:avLst/>
-          </a:prstGeom>
-          <a:noFill/>
-          <a:ln/>
-        </p:spPr>
-        <p:txBody>
-          <a:bodyPr wrap="square" lIns="0" tIns="0" rIns="0" bIns="0" rtlCol="0" anchor="t">
-            <a:normAutofit/>
-          </a:bodyPr>
-          <a:lstStyle/>
-          <a:p>
-            <a:pPr algn="l" indent="0" marL="0">
-              <a:lnSpc>
-                <a:spcPct val="133000"/>
-              </a:lnSpc>
-              <a:buNone/>
-            </a:pPr>
-            <a:r>
-              <a:rPr lang="en-US" sz="1450" b="1" dirty="0">
-                <a:solidFill>
-                  <a:srgbClr val="161613"/>
-                </a:solidFill>
-                <a:latin typeface="Inter Bold" pitchFamily="34" charset="0"/>
-                <a:ea typeface="Inter Bold" pitchFamily="34" charset="-122"/>
-                <a:cs typeface="Inter Bold" pitchFamily="34" charset="-120"/>
-              </a:rPr>
-              <a:t>+18,3%</a:t>
-            </a:r>
-            <a:pPr algn="l" indent="0" marL="0">
-              <a:lnSpc>
-                <a:spcPct val="133000"/>
-              </a:lnSpc>
-              <a:buNone/>
-            </a:pPr>
-            <a:r>
-              <a:rPr lang="en-US" sz="1450" dirty="0">
-                <a:solidFill>
-                  <a:srgbClr val="161613"/>
-                </a:solidFill>
-                <a:latin typeface="Inter" pitchFamily="34" charset="0"/>
-                <a:ea typeface="Inter" pitchFamily="34" charset="-122"/>
-                <a:cs typeface="Inter" pitchFamily="34" charset="-120"/>
-              </a:rPr>
-              <a:t> de crecimiento anual. Motor principal de ingresos en el segmento empresarial.</a:t>
-            </a:r>
-            <a:endParaRPr lang="en-US" sz="1450" dirty="0"/>
-          </a:p>
-        </p:txBody>
-      </p:sp>
-      <p:pic>
-        <p:nvPicPr>
-          <p:cNvPr id="7" name="Image 2" descr="preencoded.png">    </p:cNvPr>
+          <p:cNvPr id="4" name="Image 1" descr="preencoded.png"/>
           <p:cNvPicPr>
             <a:picLocks noChangeAspect="1"/>
           </p:cNvPicPr>
@@ -6298,7 +6041,7 @@
         </p:blipFill>
         <p:spPr>
           <a:xfrm>
-            <a:off x="661475" y="3144838"/>
+            <a:off x="661475" y="1513483"/>
             <a:ext cx="6296860" cy="1442343"/>
           </a:xfrm>
           <a:prstGeom prst="rect">
@@ -6308,13 +6051,13 @@
       </p:pic>
       <p:sp>
         <p:nvSpPr>
-          <p:cNvPr id="8" name="Text 3"/>
-          <p:cNvSpPr/>
-          <p:nvPr/>
-        </p:nvSpPr>
-        <p:spPr>
-          <a:xfrm>
-            <a:off x="977479" y="3359249"/>
+          <p:cNvPr id="5" name="Text 1"/>
+          <p:cNvSpPr/>
+          <p:nvPr/>
+        </p:nvSpPr>
+        <p:spPr>
+          <a:xfrm>
+            <a:off x="977479" y="1727895"/>
             <a:ext cx="5766449" cy="295275"/>
           </a:xfrm>
           <a:prstGeom prst="rect">
@@ -6327,7 +6070,7 @@
           <a:bodyPr wrap="none" lIns="0" tIns="0" rIns="0" bIns="0" rtlCol="0" anchor="t"/>
           <a:lstStyle/>
           <a:p>
-            <a:pPr algn="l" indent="0" marL="0">
+            <a:pPr marL="0" indent="0" algn="l">
               <a:lnSpc>
                 <a:spcPct val="104000"/>
               </a:lnSpc>
@@ -6342,7 +6085,7 @@
                 <a:ea typeface="DM Sans Medium" pitchFamily="34" charset="-122"/>
                 <a:cs typeface="DM Sans Medium" pitchFamily="34" charset="-120"/>
               </a:rPr>
-              <a:t>Servicios Residenciales</a:t>
+              <a:t>Servicios B2B Corporativos</a:t>
             </a:r>
             <a:endParaRPr lang="en-US" sz="1850" dirty="0"/>
           </a:p>
@@ -6350,13 +6093,13 @@
       </p:sp>
       <p:sp>
         <p:nvSpPr>
-          <p:cNvPr id="9" name="Text 4"/>
-          <p:cNvSpPr/>
-          <p:nvPr/>
-        </p:nvSpPr>
-        <p:spPr>
-          <a:xfrm>
-            <a:off x="977479" y="3767931"/>
+          <p:cNvPr id="6" name="Text 2"/>
+          <p:cNvSpPr/>
+          <p:nvPr/>
+        </p:nvSpPr>
+        <p:spPr>
+          <a:xfrm>
+            <a:off x="977479" y="2136577"/>
             <a:ext cx="5766449" cy="604838"/>
           </a:xfrm>
           <a:prstGeom prst="rect">
@@ -6371,7 +6114,7 @@
           </a:bodyPr>
           <a:lstStyle/>
           <a:p>
-            <a:pPr algn="l" indent="0" marL="0">
+            <a:pPr marL="0" indent="0" algn="l">
               <a:lnSpc>
                 <a:spcPct val="133000"/>
               </a:lnSpc>
@@ -6386,14 +6129,8 @@
                 <a:ea typeface="Inter Bold" pitchFamily="34" charset="-122"/>
                 <a:cs typeface="Inter Bold" pitchFamily="34" charset="-120"/>
               </a:rPr>
-              <a:t>+9,4%</a:t>
-            </a:r>
-            <a:pPr algn="l" indent="0" marL="0">
-              <a:lnSpc>
-                <a:spcPct val="133000"/>
-              </a:lnSpc>
-              <a:buNone/>
-            </a:pPr>
+              <a:t>+18,3%</a:t>
+            </a:r>
             <a:r>
               <a:rPr lang="en-US" sz="1450" dirty="0">
                 <a:solidFill>
@@ -6403,7 +6140,7 @@
                 <a:ea typeface="Inter" pitchFamily="34" charset="-122"/>
                 <a:cs typeface="Inter" pitchFamily="34" charset="-120"/>
               </a:rPr>
-              <a:t> de crecimiento. Expansión sostenida en atención al cliente y cobertura doméstica.</a:t>
+              <a:t> de crecimiento anual. Motor principal de ingresos en el segmento empresarial.</a:t>
             </a:r>
             <a:endParaRPr lang="en-US" sz="1450" dirty="0"/>
           </a:p>
@@ -6411,17 +6148,17 @@
       </p:sp>
       <p:pic>
         <p:nvPicPr>
-          <p:cNvPr id="10" name="Image 3" descr="preencoded.png">    </p:cNvPr>
+          <p:cNvPr id="7" name="Image 2" descr="preencoded.png"/>
           <p:cNvPicPr>
             <a:picLocks noChangeAspect="1"/>
           </p:cNvPicPr>
           <p:nvPr/>
         </p:nvPicPr>
         <p:blipFill>
-          <a:blip r:embed="rId6">
+          <a:blip r:embed="rId4">
             <a:extLst>
               <a:ext uri="{96DAC541-7B7A-43D3-8B79-37D633B846F1}">
-                <asvg:svgBlip xmlns:asvg="http://schemas.microsoft.com/office/drawing/2016/SVG/main" r:embed="rId7"/>
+                <asvg:svgBlip xmlns:asvg="http://schemas.microsoft.com/office/drawing/2016/SVG/main" r:embed="rId5"/>
               </a:ext>
             </a:extLst>
           </a:blip>
@@ -6431,7 +6168,7 @@
         </p:blipFill>
         <p:spPr>
           <a:xfrm>
-            <a:off x="661475" y="4776192"/>
+            <a:off x="661475" y="3144838"/>
             <a:ext cx="6296860" cy="1442343"/>
           </a:xfrm>
           <a:prstGeom prst="rect">
@@ -6441,13 +6178,13 @@
       </p:pic>
       <p:sp>
         <p:nvSpPr>
-          <p:cNvPr id="11" name="Text 5"/>
-          <p:cNvSpPr/>
-          <p:nvPr/>
-        </p:nvSpPr>
-        <p:spPr>
-          <a:xfrm>
-            <a:off x="977479" y="4990604"/>
+          <p:cNvPr id="8" name="Text 3"/>
+          <p:cNvSpPr/>
+          <p:nvPr/>
+        </p:nvSpPr>
+        <p:spPr>
+          <a:xfrm>
+            <a:off x="977479" y="3359249"/>
             <a:ext cx="5766449" cy="295275"/>
           </a:xfrm>
           <a:prstGeom prst="rect">
@@ -6460,7 +6197,7 @@
           <a:bodyPr wrap="none" lIns="0" tIns="0" rIns="0" bIns="0" rtlCol="0" anchor="t"/>
           <a:lstStyle/>
           <a:p>
-            <a:pPr algn="l" indent="0" marL="0">
+            <a:pPr marL="0" indent="0" algn="l">
               <a:lnSpc>
                 <a:spcPct val="104000"/>
               </a:lnSpc>
@@ -6475,7 +6212,7 @@
                 <a:ea typeface="DM Sans Medium" pitchFamily="34" charset="-122"/>
                 <a:cs typeface="DM Sans Medium" pitchFamily="34" charset="-120"/>
               </a:rPr>
-              <a:t>Cloud / Digital</a:t>
+              <a:t>Servicios Residenciales</a:t>
             </a:r>
             <a:endParaRPr lang="en-US" sz="1850" dirty="0"/>
           </a:p>
@@ -6483,13 +6220,13 @@
       </p:sp>
       <p:sp>
         <p:nvSpPr>
-          <p:cNvPr id="12" name="Text 6"/>
-          <p:cNvSpPr/>
-          <p:nvPr/>
-        </p:nvSpPr>
-        <p:spPr>
-          <a:xfrm>
-            <a:off x="977479" y="5399286"/>
+          <p:cNvPr id="9" name="Text 4"/>
+          <p:cNvSpPr/>
+          <p:nvPr/>
+        </p:nvSpPr>
+        <p:spPr>
+          <a:xfrm>
+            <a:off x="977479" y="3767931"/>
             <a:ext cx="5766449" cy="604838"/>
           </a:xfrm>
           <a:prstGeom prst="rect">
@@ -6504,7 +6241,7 @@
           </a:bodyPr>
           <a:lstStyle/>
           <a:p>
-            <a:pPr algn="l" indent="0" marL="0">
+            <a:pPr marL="0" indent="0" algn="l">
               <a:lnSpc>
                 <a:spcPct val="133000"/>
               </a:lnSpc>
@@ -6513,20 +6250,141 @@
             <a:r>
               <a:rPr lang="en-US" sz="1450" b="1" dirty="0">
                 <a:solidFill>
-                  <a:srgbClr val="28282F"/>
+                  <a:srgbClr val="161613"/>
                 </a:solidFill>
                 <a:latin typeface="Inter Bold" pitchFamily="34" charset="0"/>
                 <a:ea typeface="Inter Bold" pitchFamily="34" charset="-122"/>
                 <a:cs typeface="Inter Bold" pitchFamily="34" charset="-120"/>
               </a:rPr>
+              <a:t>+9,4%</a:t>
+            </a:r>
+            <a:r>
+              <a:rPr lang="en-US" sz="1450" dirty="0">
+                <a:solidFill>
+                  <a:srgbClr val="161613"/>
+                </a:solidFill>
+                <a:latin typeface="Inter" pitchFamily="34" charset="0"/>
+                <a:ea typeface="Inter" pitchFamily="34" charset="-122"/>
+                <a:cs typeface="Inter" pitchFamily="34" charset="-120"/>
+              </a:rPr>
+              <a:t> de crecimiento. Expansión sostenida en atención al cliente y cobertura doméstica.</a:t>
+            </a:r>
+            <a:endParaRPr lang="en-US" sz="1450" dirty="0"/>
+          </a:p>
+        </p:txBody>
+      </p:sp>
+      <p:pic>
+        <p:nvPicPr>
+          <p:cNvPr id="10" name="Image 3" descr="preencoded.png"/>
+          <p:cNvPicPr>
+            <a:picLocks noChangeAspect="1"/>
+          </p:cNvPicPr>
+          <p:nvPr/>
+        </p:nvPicPr>
+        <p:blipFill>
+          <a:blip r:embed="rId4">
+            <a:extLst>
+              <a:ext uri="{96DAC541-7B7A-43D3-8B79-37D633B846F1}">
+                <asvg:svgBlip xmlns:asvg="http://schemas.microsoft.com/office/drawing/2016/SVG/main" r:embed="rId5"/>
+              </a:ext>
+            </a:extLst>
+          </a:blip>
+          <a:stretch>
+            <a:fillRect/>
+          </a:stretch>
+        </p:blipFill>
+        <p:spPr>
+          <a:xfrm>
+            <a:off x="661475" y="4776192"/>
+            <a:ext cx="6296860" cy="1442343"/>
+          </a:xfrm>
+          <a:prstGeom prst="rect">
+            <a:avLst/>
+          </a:prstGeom>
+        </p:spPr>
+      </p:pic>
+      <p:sp>
+        <p:nvSpPr>
+          <p:cNvPr id="11" name="Text 5"/>
+          <p:cNvSpPr/>
+          <p:nvPr/>
+        </p:nvSpPr>
+        <p:spPr>
+          <a:xfrm>
+            <a:off x="977479" y="4990604"/>
+            <a:ext cx="5766449" cy="295275"/>
+          </a:xfrm>
+          <a:prstGeom prst="rect">
+            <a:avLst/>
+          </a:prstGeom>
+          <a:noFill/>
+          <a:ln/>
+        </p:spPr>
+        <p:txBody>
+          <a:bodyPr wrap="none" lIns="0" tIns="0" rIns="0" bIns="0" rtlCol="0" anchor="t"/>
+          <a:lstStyle/>
+          <a:p>
+            <a:pPr marL="0" indent="0" algn="l">
+              <a:lnSpc>
+                <a:spcPct val="104000"/>
+              </a:lnSpc>
+              <a:buNone/>
+            </a:pPr>
+            <a:r>
+              <a:rPr lang="en-US" sz="1850" dirty="0">
+                <a:solidFill>
+                  <a:srgbClr val="161613"/>
+                </a:solidFill>
+                <a:latin typeface="DM Sans Medium" pitchFamily="34" charset="0"/>
+                <a:ea typeface="DM Sans Medium" pitchFamily="34" charset="-122"/>
+                <a:cs typeface="DM Sans Medium" pitchFamily="34" charset="-120"/>
+              </a:rPr>
+              <a:t>Cloud / Digital</a:t>
+            </a:r>
+            <a:endParaRPr lang="en-US" sz="1850" dirty="0"/>
+          </a:p>
+        </p:txBody>
+      </p:sp>
+      <p:sp>
+        <p:nvSpPr>
+          <p:cNvPr id="12" name="Text 6"/>
+          <p:cNvSpPr/>
+          <p:nvPr/>
+        </p:nvSpPr>
+        <p:spPr>
+          <a:xfrm>
+            <a:off x="977479" y="5399286"/>
+            <a:ext cx="5766449" cy="604838"/>
+          </a:xfrm>
+          <a:prstGeom prst="rect">
+            <a:avLst/>
+          </a:prstGeom>
+          <a:noFill/>
+          <a:ln/>
+        </p:spPr>
+        <p:txBody>
+          <a:bodyPr wrap="square" lIns="0" tIns="0" rIns="0" bIns="0" rtlCol="0" anchor="t">
+            <a:normAutofit/>
+          </a:bodyPr>
+          <a:lstStyle/>
+          <a:p>
+            <a:pPr marL="0" indent="0" algn="l">
+              <a:lnSpc>
+                <a:spcPct val="133000"/>
+              </a:lnSpc>
+              <a:buNone/>
+            </a:pPr>
+            <a:r>
+              <a:rPr lang="en-US" sz="1450" b="1" dirty="0">
+                <a:solidFill>
+                  <a:srgbClr val="28282F"/>
+                </a:solidFill>
+                <a:latin typeface="Inter Bold" pitchFamily="34" charset="0"/>
+                <a:ea typeface="Inter Bold" pitchFamily="34" charset="-122"/>
+                <a:cs typeface="Inter Bold" pitchFamily="34" charset="-120"/>
+              </a:rPr>
               <a:t>+37,8%</a:t>
             </a:r>
-            <a:pPr algn="l" indent="0" marL="0">
-              <a:lnSpc>
-                <a:spcPct val="133000"/>
-              </a:lnSpc>
-              <a:buNone/>
-            </a:pPr>
             <a:r>
               <a:rPr lang="en-US" sz="1450" dirty="0">
                 <a:solidFill>
@@ -6547,6 +6405,18 @@
   <p:clrMapOvr>
     <a:masterClrMapping/>
   </p:clrMapOvr>
+  <mc:AlternateContent xmlns:mc="http://schemas.openxmlformats.org/markup-compatibility/2006">
+    <mc:Choice xmlns:p14="http://schemas.microsoft.com/office/powerpoint/2010/main" Requires="p14">
+      <p:transition spd="slow">
+        <p14:prism/>
+      </p:transition>
+    </mc:Choice>
+    <mc:Fallback>
+      <p:transition spd="slow">
+        <p:fade/>
+      </p:transition>
+    </mc:Fallback>
+  </mc:AlternateContent>
 </p:sld>
 </file>
 
@@ -6569,14 +6439,14 @@
       </p:grpSpPr>
       <p:pic>
         <p:nvPicPr>
-          <p:cNvPr id="2" name="Image 0" descr="preencoded.png">    </p:cNvPr>
+          <p:cNvPr id="2" name="Image 0" descr="preencoded.png"/>
           <p:cNvPicPr>
             <a:picLocks noChangeAspect="1"/>
           </p:cNvPicPr>
           <p:nvPr/>
         </p:nvPicPr>
         <p:blipFill>
-          <a:blip r:embed="rId1"/>
+          <a:blip r:embed="rId3"/>
           <a:stretch>
             <a:fillRect/>
           </a:stretch>
@@ -6614,7 +6484,7 @@
           </a:bodyPr>
           <a:lstStyle/>
           <a:p>
-            <a:pPr algn="l" indent="0" marL="0">
+            <a:pPr marL="0" indent="0" algn="l">
               <a:lnSpc>
                 <a:spcPct val="104000"/>
               </a:lnSpc>
@@ -6658,7 +6528,7 @@
           </a:bodyPr>
           <a:lstStyle/>
           <a:p>
-            <a:pPr algn="l" indent="0" marL="0">
+            <a:pPr marL="0" indent="0" algn="l">
               <a:lnSpc>
                 <a:spcPct val="129000"/>
               </a:lnSpc>
@@ -6675,12 +6545,6 @@
               </a:rPr>
               <a:t>El modelo analítico se apoya en un </a:t>
             </a:r>
-            <a:pPr algn="l" indent="0" marL="0">
-              <a:lnSpc>
-                <a:spcPct val="129000"/>
-              </a:lnSpc>
-              <a:buNone/>
-            </a:pPr>
             <a:r>
               <a:rPr lang="en-US" sz="1350" b="1" dirty="0">
                 <a:solidFill>
@@ -6692,12 +6556,6 @@
               </a:rPr>
               <a:t>esquema en estrella</a:t>
             </a:r>
-            <a:pPr algn="l" indent="0" marL="0">
-              <a:lnSpc>
-                <a:spcPct val="129000"/>
-              </a:lnSpc>
-              <a:buNone/>
-            </a:pPr>
             <a:r>
               <a:rPr lang="en-US" sz="1350" dirty="0">
                 <a:solidFill>
@@ -6736,7 +6594,7 @@
           </a:bodyPr>
           <a:lstStyle/>
           <a:p>
-            <a:pPr algn="l" marL="274320" indent="-274320">
+            <a:pPr marL="274320" indent="-274320" algn="l">
               <a:lnSpc>
                 <a:spcPct val="129000"/>
               </a:lnSpc>
@@ -6754,13 +6612,6 @@
               </a:rPr>
               <a:t>6 departamentos</a:t>
             </a:r>
-            <a:pPr algn="l" marL="274320" indent="-274320">
-              <a:lnSpc>
-                <a:spcPct val="129000"/>
-              </a:lnSpc>
-              <a:buSzPct val="100000"/>
-              <a:buChar char="•"/>
-            </a:pPr>
             <a:r>
               <a:rPr lang="en-US" sz="1350" dirty="0">
                 <a:solidFill>
@@ -6775,7 +6626,7 @@
             <a:endParaRPr lang="en-US" sz="1350" dirty="0"/>
           </a:p>
           <a:p>
-            <a:pPr algn="l" marL="274320" indent="-274320">
+            <a:pPr marL="274320" indent="-274320" algn="l">
               <a:lnSpc>
                 <a:spcPct val="129000"/>
               </a:lnSpc>
@@ -6793,13 +6644,6 @@
               </a:rPr>
               <a:t>Dataset limpio: </a:t>
             </a:r>
-            <a:pPr algn="l" marL="274320" indent="-274320">
-              <a:lnSpc>
-                <a:spcPct val="129000"/>
-              </a:lnSpc>
-              <a:buSzPct val="100000"/>
-              <a:buChar char="•"/>
-            </a:pPr>
             <a:r>
               <a:rPr lang="en-US" sz="1350" b="1" dirty="0">
                 <a:solidFill>
@@ -6811,13 +6655,6 @@
               </a:rPr>
               <a:t>230 de 241 registros válidos</a:t>
             </a:r>
-            <a:pPr algn="l" marL="274320" indent="-274320">
-              <a:lnSpc>
-                <a:spcPct val="129000"/>
-              </a:lnSpc>
-              <a:buSzPct val="100000"/>
-              <a:buChar char="•"/>
-            </a:pPr>
             <a:r>
               <a:rPr lang="en-US" sz="1350" dirty="0">
                 <a:solidFill>
@@ -6832,7 +6669,7 @@
             <a:endParaRPr lang="en-US" sz="1350" dirty="0"/>
           </a:p>
           <a:p>
-            <a:pPr algn="l" marL="274320" indent="-274320">
+            <a:pPr marL="274320" indent="-274320" algn="l">
               <a:lnSpc>
                 <a:spcPct val="129000"/>
               </a:lnSpc>
@@ -6875,17 +6712,24 @@
           </a:solidFill>
           <a:ln/>
         </p:spPr>
+        <p:txBody>
+          <a:bodyPr/>
+          <a:lstStyle/>
+          <a:p>
+            <a:endParaRPr lang="es-VE"/>
+          </a:p>
+        </p:txBody>
       </p:sp>
       <p:pic>
         <p:nvPicPr>
-          <p:cNvPr id="7" name="Image 1" descr="preencoded.png">    </p:cNvPr>
+          <p:cNvPr id="7" name="Image 1" descr="preencoded.png"/>
           <p:cNvPicPr>
             <a:picLocks noChangeAspect="1"/>
           </p:cNvPicPr>
           <p:nvPr/>
         </p:nvPicPr>
         <p:blipFill>
-          <a:blip r:embed="rId2"/>
+          <a:blip r:embed="rId4"/>
           <a:stretch>
             <a:fillRect/>
           </a:stretch>
@@ -6923,7 +6767,7 @@
           </a:bodyPr>
           <a:lstStyle/>
           <a:p>
-            <a:pPr algn="l" indent="0" marL="0">
+            <a:pPr marL="0" indent="0" algn="l">
               <a:lnSpc>
                 <a:spcPct val="129000"/>
               </a:lnSpc>
@@ -6949,6 +6793,18 @@
   <p:clrMapOvr>
     <a:masterClrMapping/>
   </p:clrMapOvr>
+  <mc:AlternateContent xmlns:mc="http://schemas.openxmlformats.org/markup-compatibility/2006">
+    <mc:Choice xmlns:p14="http://schemas.microsoft.com/office/powerpoint/2010/main" Requires="p14">
+      <p:transition spd="slow" p14:dur="1200">
+        <p14:prism/>
+      </p:transition>
+    </mc:Choice>
+    <mc:Fallback>
+      <p:transition spd="slow">
+        <p:fade/>
+      </p:transition>
+    </mc:Fallback>
+  </mc:AlternateContent>
 </p:sld>
 </file>
 
@@ -6990,7 +6846,7 @@
           <a:bodyPr wrap="none" lIns="0" tIns="0" rIns="0" bIns="0" rtlCol="0" anchor="t"/>
           <a:lstStyle/>
           <a:p>
-            <a:pPr algn="l" indent="0" marL="0">
+            <a:pPr marL="0" indent="0" algn="l">
               <a:lnSpc>
                 <a:spcPct val="104000"/>
               </a:lnSpc>
@@ -7013,14 +6869,14 @@
       </p:sp>
       <p:pic>
         <p:nvPicPr>
-          <p:cNvPr id="3" name="Image 0" descr="preencoded.png">    </p:cNvPr>
+          <p:cNvPr id="3" name="Image 0" descr="preencoded.png"/>
           <p:cNvPicPr>
             <a:picLocks noChangeAspect="1"/>
           </p:cNvPicPr>
           <p:nvPr/>
         </p:nvPicPr>
         <p:blipFill>
-          <a:blip r:embed="rId1"/>
+          <a:blip r:embed="rId3"/>
           <a:stretch>
             <a:fillRect/>
           </a:stretch>
@@ -7056,7 +6912,7 @@
           <a:bodyPr wrap="none" lIns="0" tIns="0" rIns="0" bIns="0" rtlCol="0" anchor="t"/>
           <a:lstStyle/>
           <a:p>
-            <a:pPr algn="l" indent="0" marL="0">
+            <a:pPr marL="0" indent="0" algn="l">
               <a:lnSpc>
                 <a:spcPct val="104000"/>
               </a:lnSpc>
@@ -7100,7 +6956,7 @@
           </a:bodyPr>
           <a:lstStyle/>
           <a:p>
-            <a:pPr algn="l" indent="0" marL="0">
+            <a:pPr marL="0" indent="0" algn="l">
               <a:lnSpc>
                 <a:spcPct val="133000"/>
               </a:lnSpc>
@@ -7117,12 +6973,6 @@
               </a:rPr>
               <a:t>Los ingresos proyectados para 2026 ascienden a </a:t>
             </a:r>
-            <a:pPr algn="l" indent="0" marL="0">
-              <a:lnSpc>
-                <a:spcPct val="133000"/>
-              </a:lnSpc>
-              <a:buNone/>
-            </a:pPr>
             <a:r>
               <a:rPr lang="en-US" sz="1450" b="1" dirty="0">
                 <a:solidFill>
@@ -7134,12 +6984,6 @@
               </a:rPr>
               <a:t>7.028.269 €</a:t>
             </a:r>
-            <a:pPr algn="l" indent="0" marL="0">
-              <a:lnSpc>
-                <a:spcPct val="133000"/>
-              </a:lnSpc>
-              <a:buNone/>
-            </a:pPr>
             <a:r>
               <a:rPr lang="en-US" sz="1450" dirty="0">
                 <a:solidFill>
@@ -7151,12 +6995,6 @@
               </a:rPr>
               <a:t>, lo que representa un crecimiento del </a:t>
             </a:r>
-            <a:pPr algn="l" indent="0" marL="0">
-              <a:lnSpc>
-                <a:spcPct val="133000"/>
-              </a:lnSpc>
-              <a:buNone/>
-            </a:pPr>
             <a:r>
               <a:rPr lang="en-US" sz="1450" b="1" dirty="0">
                 <a:solidFill>
@@ -7168,12 +7006,6 @@
               </a:rPr>
               <a:t>+15,3%</a:t>
             </a:r>
-            <a:pPr algn="l" indent="0" marL="0">
-              <a:lnSpc>
-                <a:spcPct val="133000"/>
-              </a:lnSpc>
-              <a:buNone/>
-            </a:pPr>
             <a:r>
               <a:rPr lang="en-US" sz="1450" dirty="0">
                 <a:solidFill>
@@ -7212,7 +7044,7 @@
           </a:bodyPr>
           <a:lstStyle/>
           <a:p>
-            <a:pPr algn="l" marL="294640" indent="-294640">
+            <a:pPr marL="294640" indent="-294640" algn="l">
               <a:lnSpc>
                 <a:spcPct val="133000"/>
               </a:lnSpc>
@@ -7230,13 +7062,6 @@
               </a:rPr>
               <a:t>Método:</a:t>
             </a:r>
-            <a:pPr algn="l" marL="294640" indent="-294640">
-              <a:lnSpc>
-                <a:spcPct val="133000"/>
-              </a:lnSpc>
-              <a:buSzPct val="100000"/>
-              <a:buChar char="•"/>
-            </a:pPr>
             <a:r>
               <a:rPr lang="en-US" sz="1450" dirty="0">
                 <a:solidFill>
@@ -7251,7 +7076,7 @@
             <a:endParaRPr lang="en-US" sz="1450" dirty="0"/>
           </a:p>
           <a:p>
-            <a:pPr algn="l" marL="294640" indent="-294640">
+            <a:pPr marL="294640" indent="-294640" algn="l">
               <a:lnSpc>
                 <a:spcPct val="133000"/>
               </a:lnSpc>
@@ -7269,13 +7094,6 @@
               </a:rPr>
               <a:t>Rango B2B estimado:</a:t>
             </a:r>
-            <a:pPr algn="l" marL="294640" indent="-294640">
-              <a:lnSpc>
-                <a:spcPct val="133000"/>
-              </a:lnSpc>
-              <a:buSzPct val="100000"/>
-              <a:buChar char="•"/>
-            </a:pPr>
             <a:r>
               <a:rPr lang="en-US" sz="1450" dirty="0">
                 <a:solidFill>
@@ -7314,7 +7132,7 @@
           </a:bodyPr>
           <a:lstStyle/>
           <a:p>
-            <a:pPr algn="l" indent="0" marL="0">
+            <a:pPr marL="0" indent="0" algn="l">
               <a:lnSpc>
                 <a:spcPct val="133000"/>
               </a:lnSpc>
@@ -7340,6 +7158,18 @@
   <p:clrMapOvr>
     <a:masterClrMapping/>
   </p:clrMapOvr>
+  <mc:AlternateContent xmlns:mc="http://schemas.openxmlformats.org/markup-compatibility/2006">
+    <mc:Choice xmlns:p14="http://schemas.microsoft.com/office/powerpoint/2010/main" Requires="p14">
+      <p:transition spd="slow" p14:dur="1200">
+        <p14:prism/>
+      </p:transition>
+    </mc:Choice>
+    <mc:Fallback>
+      <p:transition spd="slow">
+        <p:fade/>
+      </p:transition>
+    </mc:Fallback>
+  </mc:AlternateContent>
 </p:sld>
 </file>
 
@@ -7381,7 +7211,7 @@
           <a:bodyPr wrap="none" lIns="0" tIns="0" rIns="0" bIns="0" rtlCol="0" anchor="t"/>
           <a:lstStyle/>
           <a:p>
-            <a:pPr algn="l" indent="0" marL="0">
+            <a:pPr marL="0" indent="0" algn="l">
               <a:lnSpc>
                 <a:spcPct val="104000"/>
               </a:lnSpc>
@@ -7423,6 +7253,13 @@
           </a:solidFill>
           <a:ln/>
         </p:spPr>
+        <p:txBody>
+          <a:bodyPr/>
+          <a:lstStyle/>
+          <a:p>
+            <a:endParaRPr lang="es-VE"/>
+          </a:p>
+        </p:txBody>
       </p:sp>
       <p:sp>
         <p:nvSpPr>
@@ -7445,7 +7282,7 @@
           <a:bodyPr wrap="none" lIns="0" tIns="0" rIns="0" bIns="0" rtlCol="0" anchor="t"/>
           <a:lstStyle/>
           <a:p>
-            <a:pPr algn="l" indent="0" marL="0">
+            <a:pPr marL="0" indent="0" algn="l">
               <a:lnSpc>
                 <a:spcPct val="104000"/>
               </a:lnSpc>
@@ -7487,7 +7324,7 @@
           <a:bodyPr wrap="square" lIns="0" tIns="0" rIns="0" bIns="0" rtlCol="0" anchor="t"/>
           <a:lstStyle/>
           <a:p>
-            <a:pPr algn="l" indent="0" marL="0">
+            <a:pPr marL="0" indent="0" algn="l">
               <a:lnSpc>
                 <a:spcPct val="133000"/>
               </a:lnSpc>
@@ -7510,7 +7347,7 @@
             <a:endParaRPr lang="en-US" sz="1450" dirty="0"/>
           </a:p>
           <a:p>
-            <a:pPr algn="l" indent="0" marL="0">
+            <a:pPr marL="0" indent="0" algn="l">
               <a:lnSpc>
                 <a:spcPct val="133000"/>
               </a:lnSpc>
@@ -7552,6 +7389,13 @@
           </a:solidFill>
           <a:ln/>
         </p:spPr>
+        <p:txBody>
+          <a:bodyPr/>
+          <a:lstStyle/>
+          <a:p>
+            <a:endParaRPr lang="es-VE"/>
+          </a:p>
+        </p:txBody>
       </p:sp>
       <p:sp>
         <p:nvSpPr>
@@ -7574,7 +7418,7 @@
           <a:bodyPr wrap="none" lIns="0" tIns="0" rIns="0" bIns="0" rtlCol="0" anchor="t"/>
           <a:lstStyle/>
           <a:p>
-            <a:pPr algn="l" indent="0" marL="0">
+            <a:pPr marL="0" indent="0" algn="l">
               <a:lnSpc>
                 <a:spcPct val="104000"/>
               </a:lnSpc>
@@ -7616,7 +7460,7 @@
           <a:bodyPr wrap="square" lIns="0" tIns="0" rIns="0" bIns="0" rtlCol="0" anchor="t"/>
           <a:lstStyle/>
           <a:p>
-            <a:pPr algn="l" indent="0" marL="0">
+            <a:pPr marL="0" indent="0" algn="l">
               <a:lnSpc>
                 <a:spcPct val="133000"/>
               </a:lnSpc>
@@ -7639,7 +7483,7 @@
             <a:endParaRPr lang="en-US" sz="1450" dirty="0"/>
           </a:p>
           <a:p>
-            <a:pPr algn="l" indent="0" marL="0">
+            <a:pPr marL="0" indent="0" algn="l">
               <a:lnSpc>
                 <a:spcPct val="133000"/>
               </a:lnSpc>
@@ -7681,6 +7525,13 @@
           </a:solidFill>
           <a:ln/>
         </p:spPr>
+        <p:txBody>
+          <a:bodyPr/>
+          <a:lstStyle/>
+          <a:p>
+            <a:endParaRPr lang="es-VE"/>
+          </a:p>
+        </p:txBody>
       </p:sp>
       <p:sp>
         <p:nvSpPr>
@@ -7703,7 +7554,7 @@
           <a:bodyPr wrap="none" lIns="0" tIns="0" rIns="0" bIns="0" rtlCol="0" anchor="t"/>
           <a:lstStyle/>
           <a:p>
-            <a:pPr algn="l" indent="0" marL="0">
+            <a:pPr marL="0" indent="0" algn="l">
               <a:lnSpc>
                 <a:spcPct val="104000"/>
               </a:lnSpc>
@@ -7745,7 +7596,7 @@
           <a:bodyPr wrap="square" lIns="0" tIns="0" rIns="0" bIns="0" rtlCol="0" anchor="t"/>
           <a:lstStyle/>
           <a:p>
-            <a:pPr algn="l" indent="0" marL="0">
+            <a:pPr marL="0" indent="0" algn="l">
               <a:lnSpc>
                 <a:spcPct val="133000"/>
               </a:lnSpc>
@@ -7768,7 +7619,7 @@
             <a:endParaRPr lang="en-US" sz="1450" dirty="0"/>
           </a:p>
           <a:p>
-            <a:pPr algn="l" indent="0" marL="0">
+            <a:pPr marL="0" indent="0" algn="l">
               <a:lnSpc>
                 <a:spcPct val="133000"/>
               </a:lnSpc>
@@ -7785,12 +7636,6 @@
               </a:rPr>
               <a:t>Mejora de </a:t>
             </a:r>
-            <a:pPr algn="l" indent="0" marL="0">
-              <a:lnSpc>
-                <a:spcPct val="133000"/>
-              </a:lnSpc>
-              <a:buNone/>
-            </a:pPr>
             <a:r>
               <a:rPr lang="en-US" sz="1450" b="1" dirty="0">
                 <a:solidFill>
@@ -7802,12 +7647,6 @@
               </a:rPr>
               <a:t>+4,9 p.p.</a:t>
             </a:r>
-            <a:pPr algn="l" indent="0" marL="0">
-              <a:lnSpc>
-                <a:spcPct val="133000"/>
-              </a:lnSpc>
-              <a:buNone/>
-            </a:pPr>
             <a:r>
               <a:rPr lang="en-US" sz="1450" dirty="0">
                 <a:solidFill>
@@ -7828,6 +7667,18 @@
   <p:clrMapOvr>
     <a:masterClrMapping/>
   </p:clrMapOvr>
+  <mc:AlternateContent xmlns:mc="http://schemas.openxmlformats.org/markup-compatibility/2006">
+    <mc:Choice xmlns:p14="http://schemas.microsoft.com/office/powerpoint/2010/main" Requires="p14">
+      <p:transition spd="slow" p14:dur="1200">
+        <p14:prism/>
+      </p:transition>
+    </mc:Choice>
+    <mc:Fallback>
+      <p:transition spd="slow">
+        <p:fade/>
+      </p:transition>
+    </mc:Fallback>
+  </mc:AlternateContent>
 </p:sld>
 </file>
 
@@ -8124,4 +7975,319 @@
     </a:ext>
   </a:extLst>
 </a:theme>
+</file>
+
+<file path=ppt/theme/theme2.xml><?xml version="1.0" encoding="utf-8"?>
+<a:theme xmlns:a="http://schemas.openxmlformats.org/drawingml/2006/main" name="Tema de Office">
+  <a:themeElements>
+    <a:clrScheme name="Office">
+      <a:dk1>
+        <a:sysClr val="windowText" lastClr="000000"/>
+      </a:dk1>
+      <a:lt1>
+        <a:sysClr val="window" lastClr="FFFFFF"/>
+      </a:lt1>
+      <a:dk2>
+        <a:srgbClr val="0E2841"/>
+      </a:dk2>
+      <a:lt2>
+        <a:srgbClr val="E8E8E8"/>
+      </a:lt2>
+      <a:accent1>
+        <a:srgbClr val="156082"/>
+      </a:accent1>
+      <a:accent2>
+        <a:srgbClr val="E97132"/>
+      </a:accent2>
+      <a:accent3>
+        <a:srgbClr val="196B24"/>
+      </a:accent3>
+      <a:accent4>
+        <a:srgbClr val="0F9ED5"/>
+      </a:accent4>
+      <a:accent5>
+        <a:srgbClr val="A02B93"/>
+      </a:accent5>
+      <a:accent6>
+        <a:srgbClr val="4EA72E"/>
+      </a:accent6>
+      <a:hlink>
+        <a:srgbClr val="467886"/>
+      </a:hlink>
+      <a:folHlink>
+        <a:srgbClr val="96607D"/>
+      </a:folHlink>
+    </a:clrScheme>
+    <a:fontScheme name="Office">
+      <a:majorFont>
+        <a:latin typeface="Aptos Display" panose="02110004020202020204"/>
+        <a:ea typeface=""/>
+        <a:cs typeface=""/>
+        <a:font script="Jpan" typeface="游ゴシック Light"/>
+        <a:font script="Hang" typeface="맑은 고딕"/>
+        <a:font script="Hans" typeface="等线 Light"/>
+        <a:font script="Hant" typeface="新細明體"/>
+        <a:font script="Arab" typeface="Times New Roman"/>
+        <a:font script="Hebr" typeface="Times New Roman"/>
+        <a:font script="Thai" typeface="Angsana New"/>
+        <a:font script="Ethi" typeface="Nyala"/>
+        <a:font script="Beng" typeface="Vrinda"/>
+        <a:font script="Gujr" typeface="Shruti"/>
+        <a:font script="Khmr" typeface="MoolBoran"/>
+        <a:font script="Knda" typeface="Tunga"/>
+        <a:font script="Guru" typeface="Raavi"/>
+        <a:font script="Cans" typeface="Euphemia"/>
+        <a:font script="Cher" typeface="Plantagenet Cherokee"/>
+        <a:font script="Yiii" typeface="Microsoft Yi Baiti"/>
+        <a:font script="Tibt" typeface="Microsoft Himalaya"/>
+        <a:font script="Thaa" typeface="MV Boli"/>
+        <a:font script="Deva" typeface="Mangal"/>
+        <a:font script="Telu" typeface="Gautami"/>
+        <a:font script="Taml" typeface="Latha"/>
+        <a:font script="Syrc" typeface="Estrangelo Edessa"/>
+        <a:font script="Orya" typeface="Kalinga"/>
+        <a:font script="Mlym" typeface="Kartika"/>
+        <a:font script="Laoo" typeface="DokChampa"/>
+        <a:font script="Sinh" typeface="Iskoola Pota"/>
+        <a:font script="Mong" typeface="Mongolian Baiti"/>
+        <a:font script="Viet" typeface="Times New Roman"/>
+        <a:font script="Uigh" typeface="Microsoft Uighur"/>
+        <a:font script="Geor" typeface="Sylfaen"/>
+        <a:font script="Armn" typeface="Arial"/>
+        <a:font script="Bugi" typeface="Leelawadee UI"/>
+        <a:font script="Bopo" typeface="Microsoft JhengHei"/>
+        <a:font script="Java" typeface="Javanese Text"/>
+        <a:font script="Lisu" typeface="Segoe UI"/>
+        <a:font script="Mymr" typeface="Myanmar Text"/>
+        <a:font script="Nkoo" typeface="Ebrima"/>
+        <a:font script="Olck" typeface="Nirmala UI"/>
+        <a:font script="Osma" typeface="Ebrima"/>
+        <a:font script="Phag" typeface="Phagspa"/>
+        <a:font script="Syrn" typeface="Estrangelo Edessa"/>
+        <a:font script="Syrj" typeface="Estrangelo Edessa"/>
+        <a:font script="Syre" typeface="Estrangelo Edessa"/>
+        <a:font script="Sora" typeface="Nirmala UI"/>
+        <a:font script="Tale" typeface="Microsoft Tai Le"/>
+        <a:font script="Talu" typeface="Microsoft New Tai Lue"/>
+        <a:font script="Tfng" typeface="Ebrima"/>
+      </a:majorFont>
+      <a:minorFont>
+        <a:latin typeface="Aptos" panose="02110004020202020204"/>
+        <a:ea typeface=""/>
+        <a:cs typeface=""/>
+        <a:font script="Jpan" typeface="游ゴシック"/>
+        <a:font script="Hang" typeface="맑은 고딕"/>
+        <a:font script="Hans" typeface="等线"/>
+        <a:font script="Hant" typeface="新細明體"/>
+        <a:font script="Arab" typeface="Arial"/>
+        <a:font script="Hebr" typeface="Arial"/>
+        <a:font script="Thai" typeface="Cordia New"/>
+        <a:font script="Ethi" typeface="Nyala"/>
+        <a:font script="Beng" typeface="Vrinda"/>
+        <a:font script="Gujr" typeface="Shruti"/>
+        <a:font script="Khmr" typeface="DaunPenh"/>
+        <a:font script="Knda" typeface="Tunga"/>
+        <a:font script="Guru" typeface="Raavi"/>
+        <a:font script="Cans" typeface="Euphemia"/>
+        <a:font script="Cher" typeface="Plantagenet Cherokee"/>
+        <a:font script="Yiii" typeface="Microsoft Yi Baiti"/>
+        <a:font script="Tibt" typeface="Microsoft Himalaya"/>
+        <a:font script="Thaa" typeface="MV Boli"/>
+        <a:font script="Deva" typeface="Mangal"/>
+        <a:font script="Telu" typeface="Gautami"/>
+        <a:font script="Taml" typeface="Latha"/>
+        <a:font script="Syrc" typeface="Estrangelo Edessa"/>
+        <a:font script="Orya" typeface="Kalinga"/>
+        <a:font script="Mlym" typeface="Kartika"/>
+        <a:font script="Laoo" typeface="DokChampa"/>
+        <a:font script="Sinh" typeface="Iskoola Pota"/>
+        <a:font script="Mong" typeface="Mongolian Baiti"/>
+        <a:font script="Viet" typeface="Arial"/>
+        <a:font script="Uigh" typeface="Microsoft Uighur"/>
+        <a:font script="Geor" typeface="Sylfaen"/>
+        <a:font script="Armn" typeface="Arial"/>
+        <a:font script="Bugi" typeface="Leelawadee UI"/>
+        <a:font script="Bopo" typeface="Microsoft JhengHei"/>
+        <a:font script="Java" typeface="Javanese Text"/>
+        <a:font script="Lisu" typeface="Segoe UI"/>
+        <a:font script="Mymr" typeface="Myanmar Text"/>
+        <a:font script="Nkoo" typeface="Ebrima"/>
+        <a:font script="Olck" typeface="Nirmala UI"/>
+        <a:font script="Osma" typeface="Ebrima"/>
+        <a:font script="Phag" typeface="Phagspa"/>
+        <a:font script="Syrn" typeface="Estrangelo Edessa"/>
+        <a:font script="Syrj" typeface="Estrangelo Edessa"/>
+        <a:font script="Syre" typeface="Estrangelo Edessa"/>
+        <a:font script="Sora" typeface="Nirmala UI"/>
+        <a:font script="Tale" typeface="Microsoft Tai Le"/>
+        <a:font script="Talu" typeface="Microsoft New Tai Lue"/>
+        <a:font script="Tfng" typeface="Ebrima"/>
+      </a:minorFont>
+    </a:fontScheme>
+    <a:fmtScheme name="Office">
+      <a:fillStyleLst>
+        <a:solidFill>
+          <a:schemeClr val="phClr"/>
+        </a:solidFill>
+        <a:gradFill rotWithShape="1">
+          <a:gsLst>
+            <a:gs pos="0">
+              <a:schemeClr val="phClr">
+                <a:lumMod val="110000"/>
+                <a:satMod val="105000"/>
+                <a:tint val="67000"/>
+              </a:schemeClr>
+            </a:gs>
+            <a:gs pos="50000">
+              <a:schemeClr val="phClr">
+                <a:lumMod val="105000"/>
+                <a:satMod val="103000"/>
+                <a:tint val="73000"/>
+              </a:schemeClr>
+            </a:gs>
+            <a:gs pos="100000">
+              <a:schemeClr val="phClr">
+                <a:lumMod val="105000"/>
+                <a:satMod val="109000"/>
+                <a:tint val="81000"/>
+              </a:schemeClr>
+            </a:gs>
+          </a:gsLst>
+          <a:lin ang="5400000" scaled="0"/>
+        </a:gradFill>
+        <a:gradFill rotWithShape="1">
+          <a:gsLst>
+            <a:gs pos="0">
+              <a:schemeClr val="phClr">
+                <a:satMod val="103000"/>
+                <a:lumMod val="102000"/>
+                <a:tint val="94000"/>
+              </a:schemeClr>
+            </a:gs>
+            <a:gs pos="50000">
+              <a:schemeClr val="phClr">
+                <a:satMod val="110000"/>
+                <a:lumMod val="100000"/>
+                <a:shade val="100000"/>
+              </a:schemeClr>
+            </a:gs>
+            <a:gs pos="100000">
+              <a:schemeClr val="phClr">
+                <a:lumMod val="99000"/>
+                <a:satMod val="120000"/>
+                <a:shade val="78000"/>
+              </a:schemeClr>
+            </a:gs>
+          </a:gsLst>
+          <a:lin ang="5400000" scaled="0"/>
+        </a:gradFill>
+      </a:fillStyleLst>
+      <a:lnStyleLst>
+        <a:ln w="12700" cap="flat" cmpd="sng" algn="ctr">
+          <a:solidFill>
+            <a:schemeClr val="phClr"/>
+          </a:solidFill>
+          <a:prstDash val="solid"/>
+          <a:miter lim="800000"/>
+        </a:ln>
+        <a:ln w="19050" cap="flat" cmpd="sng" algn="ctr">
+          <a:solidFill>
+            <a:schemeClr val="phClr"/>
+          </a:solidFill>
+          <a:prstDash val="solid"/>
+          <a:miter lim="800000"/>
+        </a:ln>
+        <a:ln w="25400" cap="flat" cmpd="sng" algn="ctr">
+          <a:solidFill>
+            <a:schemeClr val="phClr"/>
+          </a:solidFill>
+          <a:prstDash val="solid"/>
+          <a:miter lim="800000"/>
+        </a:ln>
+      </a:lnStyleLst>
+      <a:effectStyleLst>
+        <a:effectStyle>
+          <a:effectLst/>
+        </a:effectStyle>
+        <a:effectStyle>
+          <a:effectLst/>
+        </a:effectStyle>
+        <a:effectStyle>
+          <a:effectLst>
+            <a:outerShdw blurRad="57150" dist="19050" dir="5400000" algn="ctr" rotWithShape="0">
+              <a:srgbClr val="000000">
+                <a:alpha val="63000"/>
+              </a:srgbClr>
+            </a:outerShdw>
+          </a:effectLst>
+        </a:effectStyle>
+      </a:effectStyleLst>
+      <a:bgFillStyleLst>
+        <a:solidFill>
+          <a:schemeClr val="phClr"/>
+        </a:solidFill>
+        <a:solidFill>
+          <a:schemeClr val="phClr">
+            <a:tint val="95000"/>
+            <a:satMod val="170000"/>
+          </a:schemeClr>
+        </a:solidFill>
+        <a:gradFill rotWithShape="1">
+          <a:gsLst>
+            <a:gs pos="0">
+              <a:schemeClr val="phClr">
+                <a:tint val="93000"/>
+                <a:satMod val="150000"/>
+                <a:shade val="98000"/>
+                <a:lumMod val="102000"/>
+              </a:schemeClr>
+            </a:gs>
+            <a:gs pos="50000">
+              <a:schemeClr val="phClr">
+                <a:tint val="98000"/>
+                <a:satMod val="130000"/>
+                <a:shade val="90000"/>
+                <a:lumMod val="103000"/>
+              </a:schemeClr>
+            </a:gs>
+            <a:gs pos="100000">
+              <a:schemeClr val="phClr">
+                <a:shade val="63000"/>
+                <a:satMod val="120000"/>
+              </a:schemeClr>
+            </a:gs>
+          </a:gsLst>
+          <a:lin ang="5400000" scaled="0"/>
+        </a:gradFill>
+      </a:bgFillStyleLst>
+    </a:fmtScheme>
+  </a:themeElements>
+  <a:objectDefaults>
+    <a:lnDef>
+      <a:spPr/>
+      <a:bodyPr/>
+      <a:lstStyle/>
+      <a:style>
+        <a:lnRef idx="2">
+          <a:schemeClr val="accent1"/>
+        </a:lnRef>
+        <a:fillRef idx="0">
+          <a:schemeClr val="accent1"/>
+        </a:fillRef>
+        <a:effectRef idx="1">
+          <a:schemeClr val="accent1"/>
+        </a:effectRef>
+        <a:fontRef idx="minor">
+          <a:schemeClr val="tx1"/>
+        </a:fontRef>
+      </a:style>
+    </a:lnDef>
+  </a:objectDefaults>
+  <a:extraClrSchemeLst/>
+  <a:extLst>
+    <a:ext uri="{05A4C25C-085E-4340-85A3-A5531E510DB2}">
+      <thm15:themeFamily xmlns:thm15="http://schemas.microsoft.com/office/thememl/2012/main" name="Office Theme" id="{2E142A2C-CD16-42D6-873A-C26D2A0506FA}" vid="{1BDDFF52-6CD6-40A5-AB3C-68EB2F1E4D0A}"/>
+    </a:ext>
+  </a:extLst>
+</a:theme>
 </file>
</xml_diff>

<commit_message>
cambios en Power BI
</commit_message>
<xml_diff>
--- a/NEW-WORLD-TELECOM.pptx
+++ b/NEW-WORLD-TELECOM.pptx
@@ -2685,7 +2685,51 @@
                 <a:ea typeface="Inter" pitchFamily="34" charset="-122"/>
                 <a:cs typeface="Inter" pitchFamily="34" charset="-120"/>
               </a:rPr>
-              <a:t> de sobreejecución (&gt;10%) detectadas en 2025.</a:t>
+              <a:t> de </a:t>
+            </a:r>
+            <a:r>
+              <a:rPr lang="en-US" sz="1450" dirty="0" err="1">
+                <a:solidFill>
+                  <a:srgbClr val="161613"/>
+                </a:solidFill>
+                <a:latin typeface="Inter" pitchFamily="34" charset="0"/>
+                <a:ea typeface="Inter" pitchFamily="34" charset="-122"/>
+                <a:cs typeface="Inter" pitchFamily="34" charset="-120"/>
+              </a:rPr>
+              <a:t>sobre</a:t>
+            </a:r>
+            <a:r>
+              <a:rPr lang="en-US" sz="1450" dirty="0">
+                <a:solidFill>
+                  <a:srgbClr val="161613"/>
+                </a:solidFill>
+                <a:latin typeface="Inter" pitchFamily="34" charset="0"/>
+                <a:ea typeface="Inter" pitchFamily="34" charset="-122"/>
+                <a:cs typeface="Inter" pitchFamily="34" charset="-120"/>
+              </a:rPr>
+              <a:t> </a:t>
+            </a:r>
+            <a:r>
+              <a:rPr lang="en-US" sz="1450" dirty="0" err="1">
+                <a:solidFill>
+                  <a:srgbClr val="161613"/>
+                </a:solidFill>
+                <a:latin typeface="Inter" pitchFamily="34" charset="0"/>
+                <a:ea typeface="Inter" pitchFamily="34" charset="-122"/>
+                <a:cs typeface="Inter" pitchFamily="34" charset="-120"/>
+              </a:rPr>
+              <a:t>ejecución</a:t>
+            </a:r>
+            <a:r>
+              <a:rPr lang="en-US" sz="1450" dirty="0">
+                <a:solidFill>
+                  <a:srgbClr val="161613"/>
+                </a:solidFill>
+                <a:latin typeface="Inter" pitchFamily="34" charset="0"/>
+                <a:ea typeface="Inter" pitchFamily="34" charset="-122"/>
+                <a:cs typeface="Inter" pitchFamily="34" charset="-120"/>
+              </a:rPr>
+              <a:t> (&gt;10%) detectadas en 2025.</a:t>
             </a:r>
             <a:endParaRPr lang="en-US" sz="1450" dirty="0"/>
           </a:p>

</xml_diff>

<commit_message>
se guardan ultimos cambios
</commit_message>
<xml_diff>
--- a/NEW-WORLD-TELECOM.pptx
+++ b/NEW-WORLD-TELECOM.pptx
@@ -4092,7 +4092,7 @@
                 <a:ea typeface="Inter" pitchFamily="34" charset="-122"/>
                 <a:cs typeface="Inter" pitchFamily="34" charset="-120"/>
               </a:rPr>
-              <a:t>Explore un </a:t>
+              <a:t>Explore un meticuloso proceso para asegurar la calidad y confiabilidad de los datos que </a:t>
             </a:r>
             <a:r>
               <a:rPr lang="en-US" sz="1350" dirty="0" err="1">
@@ -4103,7 +4103,7 @@
                 <a:ea typeface="Inter" pitchFamily="34" charset="-122"/>
                 <a:cs typeface="Inter" pitchFamily="34" charset="-120"/>
               </a:rPr>
-              <a:t>meticuloso</a:t>
+              <a:t>impulsan</a:t>
             </a:r>
             <a:r>
               <a:rPr lang="en-US" sz="1350" dirty="0">
@@ -4114,40 +4114,7 @@
                 <a:ea typeface="Inter" pitchFamily="34" charset="-122"/>
                 <a:cs typeface="Inter" pitchFamily="34" charset="-120"/>
               </a:rPr>
-              <a:t> proceso para asegurar la calidad y confiabilidad de los datos que </a:t>
-            </a:r>
-            <a:r>
-              <a:rPr lang="en-US" sz="1350" dirty="0" err="1">
-                <a:solidFill>
-                  <a:srgbClr val="161613"/>
-                </a:solidFill>
-                <a:latin typeface="Inter" pitchFamily="34" charset="0"/>
-                <a:ea typeface="Inter" pitchFamily="34" charset="-122"/>
-                <a:cs typeface="Inter" pitchFamily="34" charset="-120"/>
-              </a:rPr>
-              <a:t>impulsan</a:t>
-            </a:r>
-            <a:r>
-              <a:rPr lang="en-US" sz="1350">
-                <a:solidFill>
-                  <a:srgbClr val="161613"/>
-                </a:solidFill>
-                <a:latin typeface="Inter" pitchFamily="34" charset="0"/>
-                <a:ea typeface="Inter" pitchFamily="34" charset="-122"/>
-                <a:cs typeface="Inter" pitchFamily="34" charset="-120"/>
-              </a:rPr>
-              <a:t> las </a:t>
-            </a:r>
-            <a:r>
-              <a:rPr lang="en-US" sz="1350" dirty="0">
-                <a:solidFill>
-                  <a:srgbClr val="161613"/>
-                </a:solidFill>
-                <a:latin typeface="Inter" pitchFamily="34" charset="0"/>
-                <a:ea typeface="Inter" pitchFamily="34" charset="-122"/>
-                <a:cs typeface="Inter" pitchFamily="34" charset="-120"/>
-              </a:rPr>
-              <a:t>decisiones estratégicas.</a:t>
+              <a:t> las decisiones estratégicas.</a:t>
             </a:r>
             <a:endParaRPr lang="en-US" sz="1350" dirty="0"/>
           </a:p>

</xml_diff>